<commit_message>
updated the presentation for one last time!
</commit_message>
<xml_diff>
--- a/MSAR_Findings.pptx
+++ b/MSAR_Findings.pptx
@@ -5,7 +5,7 @@
     <p:sldMasterId id="2147483660" r:id="rId4"/>
   </p:sldMasterIdLst>
   <p:notesMasterIdLst>
-    <p:notesMasterId r:id="rId16"/>
+    <p:notesMasterId r:id="rId17"/>
   </p:notesMasterIdLst>
   <p:sldIdLst>
     <p:sldId id="256" r:id="rId5"/>
@@ -19,6 +19,7 @@
     <p:sldId id="262" r:id="rId13"/>
     <p:sldId id="266" r:id="rId14"/>
     <p:sldId id="267" r:id="rId15"/>
+    <p:sldId id="269" r:id="rId16"/>
   </p:sldIdLst>
   <p:sldSz cx="12192000" cy="6858000"/>
   <p:notesSz cx="6858000" cy="9144000"/>
@@ -207,7 +208,7 @@
           <a:p>
             <a:fld id="{142A25F1-9CB4-574D-9A10-2031563C4788}" type="datetimeFigureOut">
               <a:rPr lang="en-US" smtClean="0"/>
-              <a:t>12/8/2025</a:t>
+              <a:t>12/9/2025</a:t>
             </a:fld>
             <a:endParaRPr lang="en-US"/>
           </a:p>
@@ -670,7 +671,7 @@
           <a:p>
             <a:fld id="{C398FABF-7BBB-4FC4-B3E3-346BCB227DD6}" type="datetimeFigureOut">
               <a:rPr lang="en-US" smtClean="0"/>
-              <a:t>12/8/2025</a:t>
+              <a:t>12/9/2025</a:t>
             </a:fld>
             <a:endParaRPr lang="en-US"/>
           </a:p>
@@ -951,7 +952,7 @@
           <a:p>
             <a:fld id="{C398FABF-7BBB-4FC4-B3E3-346BCB227DD6}" type="datetimeFigureOut">
               <a:rPr lang="en-US" smtClean="0"/>
-              <a:t>12/8/2025</a:t>
+              <a:t>12/9/2025</a:t>
             </a:fld>
             <a:endParaRPr lang="en-US"/>
           </a:p>
@@ -1143,7 +1144,7 @@
           <a:p>
             <a:fld id="{C398FABF-7BBB-4FC4-B3E3-346BCB227DD6}" type="datetimeFigureOut">
               <a:rPr lang="en-US" smtClean="0"/>
-              <a:t>12/8/2025</a:t>
+              <a:t>12/9/2025</a:t>
             </a:fld>
             <a:endParaRPr lang="en-US"/>
           </a:p>
@@ -1404,7 +1405,7 @@
           <a:p>
             <a:fld id="{C398FABF-7BBB-4FC4-B3E3-346BCB227DD6}" type="datetimeFigureOut">
               <a:rPr lang="en-US" smtClean="0"/>
-              <a:t>12/8/2025</a:t>
+              <a:t>12/9/2025</a:t>
             </a:fld>
             <a:endParaRPr lang="en-US"/>
           </a:p>
@@ -1830,7 +1831,7 @@
           <a:p>
             <a:fld id="{C398FABF-7BBB-4FC4-B3E3-346BCB227DD6}" type="datetimeFigureOut">
               <a:rPr lang="en-US" smtClean="0"/>
-              <a:t>12/8/2025</a:t>
+              <a:t>12/9/2025</a:t>
             </a:fld>
             <a:endParaRPr lang="en-US"/>
           </a:p>
@@ -2376,7 +2377,7 @@
           <a:p>
             <a:fld id="{C398FABF-7BBB-4FC4-B3E3-346BCB227DD6}" type="datetimeFigureOut">
               <a:rPr lang="en-US" smtClean="0"/>
-              <a:t>12/8/2025</a:t>
+              <a:t>12/9/2025</a:t>
             </a:fld>
             <a:endParaRPr lang="en-US"/>
           </a:p>
@@ -3207,7 +3208,7 @@
           <a:p>
             <a:fld id="{C398FABF-7BBB-4FC4-B3E3-346BCB227DD6}" type="datetimeFigureOut">
               <a:rPr lang="en-US" smtClean="0"/>
-              <a:t>12/8/2025</a:t>
+              <a:t>12/9/2025</a:t>
             </a:fld>
             <a:endParaRPr lang="en-US"/>
           </a:p>
@@ -3377,7 +3378,7 @@
           <a:p>
             <a:fld id="{C398FABF-7BBB-4FC4-B3E3-346BCB227DD6}" type="datetimeFigureOut">
               <a:rPr lang="en-US" smtClean="0"/>
-              <a:t>12/8/2025</a:t>
+              <a:t>12/9/2025</a:t>
             </a:fld>
             <a:endParaRPr lang="en-US"/>
           </a:p>
@@ -3557,7 +3558,7 @@
           <a:p>
             <a:fld id="{C398FABF-7BBB-4FC4-B3E3-346BCB227DD6}" type="datetimeFigureOut">
               <a:rPr lang="en-US" smtClean="0"/>
-              <a:t>12/8/2025</a:t>
+              <a:t>12/9/2025</a:t>
             </a:fld>
             <a:endParaRPr lang="en-US"/>
           </a:p>
@@ -3727,7 +3728,7 @@
           <a:p>
             <a:fld id="{C398FABF-7BBB-4FC4-B3E3-346BCB227DD6}" type="datetimeFigureOut">
               <a:rPr lang="en-US" smtClean="0"/>
-              <a:t>12/8/2025</a:t>
+              <a:t>12/9/2025</a:t>
             </a:fld>
             <a:endParaRPr lang="en-US"/>
           </a:p>
@@ -3984,7 +3985,7 @@
           <a:p>
             <a:fld id="{C398FABF-7BBB-4FC4-B3E3-346BCB227DD6}" type="datetimeFigureOut">
               <a:rPr lang="en-US" smtClean="0"/>
-              <a:t>12/8/2025</a:t>
+              <a:t>12/9/2025</a:t>
             </a:fld>
             <a:endParaRPr lang="en-US"/>
           </a:p>
@@ -4216,7 +4217,7 @@
           <a:p>
             <a:fld id="{C398FABF-7BBB-4FC4-B3E3-346BCB227DD6}" type="datetimeFigureOut">
               <a:rPr lang="en-US" smtClean="0"/>
-              <a:t>12/8/2025</a:t>
+              <a:t>12/9/2025</a:t>
             </a:fld>
             <a:endParaRPr lang="en-US"/>
           </a:p>
@@ -4609,7 +4610,7 @@
           <a:p>
             <a:fld id="{C398FABF-7BBB-4FC4-B3E3-346BCB227DD6}" type="datetimeFigureOut">
               <a:rPr lang="en-US" smtClean="0"/>
-              <a:t>12/8/2025</a:t>
+              <a:t>12/9/2025</a:t>
             </a:fld>
             <a:endParaRPr lang="en-US"/>
           </a:p>
@@ -4727,7 +4728,7 @@
           <a:p>
             <a:fld id="{C398FABF-7BBB-4FC4-B3E3-346BCB227DD6}" type="datetimeFigureOut">
               <a:rPr lang="en-US" smtClean="0"/>
-              <a:t>12/8/2025</a:t>
+              <a:t>12/9/2025</a:t>
             </a:fld>
             <a:endParaRPr lang="en-US"/>
           </a:p>
@@ -4822,7 +4823,7 @@
           <a:p>
             <a:fld id="{C398FABF-7BBB-4FC4-B3E3-346BCB227DD6}" type="datetimeFigureOut">
               <a:rPr lang="en-US" smtClean="0"/>
-              <a:t>12/8/2025</a:t>
+              <a:t>12/9/2025</a:t>
             </a:fld>
             <a:endParaRPr lang="en-US"/>
           </a:p>
@@ -5095,7 +5096,7 @@
           <a:p>
             <a:fld id="{C398FABF-7BBB-4FC4-B3E3-346BCB227DD6}" type="datetimeFigureOut">
               <a:rPr lang="en-US" smtClean="0"/>
-              <a:t>12/8/2025</a:t>
+              <a:t>12/9/2025</a:t>
             </a:fld>
             <a:endParaRPr lang="en-US"/>
           </a:p>
@@ -5376,7 +5377,7 @@
           <a:p>
             <a:fld id="{C398FABF-7BBB-4FC4-B3E3-346BCB227DD6}" type="datetimeFigureOut">
               <a:rPr lang="en-US" smtClean="0"/>
-              <a:t>12/8/2025</a:t>
+              <a:t>12/9/2025</a:t>
             </a:fld>
             <a:endParaRPr lang="en-US"/>
           </a:p>
@@ -5616,7 +5617,7 @@
           <a:p>
             <a:fld id="{C398FABF-7BBB-4FC4-B3E3-346BCB227DD6}" type="datetimeFigureOut">
               <a:rPr lang="en-US" smtClean="0"/>
-              <a:t>12/8/2025</a:t>
+              <a:t>12/9/2025</a:t>
             </a:fld>
             <a:endParaRPr lang="en-US"/>
           </a:p>
@@ -6479,6 +6480,71 @@
     <p:extLst>
       <p:ext uri="{BB962C8B-B14F-4D97-AF65-F5344CB8AC3E}">
         <p14:creationId xmlns:p14="http://schemas.microsoft.com/office/powerpoint/2010/main" val="517600751"/>
+      </p:ext>
+    </p:extLst>
+  </p:cSld>
+  <p:clrMapOvr>
+    <a:masterClrMapping/>
+  </p:clrMapOvr>
+</p:sld>
+</file>
+
+<file path=ppt/slides/slide12.xml><?xml version="1.0" encoding="utf-8"?>
+<p:sld xmlns:a="http://schemas.openxmlformats.org/drawingml/2006/main" xmlns:r="http://schemas.openxmlformats.org/officeDocument/2006/relationships" xmlns:p="http://schemas.openxmlformats.org/presentationml/2006/main">
+  <p:cSld>
+    <p:spTree>
+      <p:nvGrpSpPr>
+        <p:cNvPr id="1" name=""/>
+        <p:cNvGrpSpPr/>
+        <p:nvPr/>
+      </p:nvGrpSpPr>
+      <p:grpSpPr>
+        <a:xfrm>
+          <a:off x="0" y="0"/>
+          <a:ext cx="0" cy="0"/>
+          <a:chOff x="0" y="0"/>
+          <a:chExt cx="0" cy="0"/>
+        </a:xfrm>
+      </p:grpSpPr>
+      <p:sp>
+        <p:nvSpPr>
+          <p:cNvPr id="2" name="Title 1">
+            <a:extLst>
+              <a:ext uri="{FF2B5EF4-FFF2-40B4-BE49-F238E27FC236}">
+                <a16:creationId xmlns:a16="http://schemas.microsoft.com/office/drawing/2014/main" id="{ED56849F-805A-CD0E-77D2-C28D9D91AEDD}"/>
+              </a:ext>
+            </a:extLst>
+          </p:cNvPr>
+          <p:cNvSpPr>
+            <a:spLocks noGrp="1"/>
+          </p:cNvSpPr>
+          <p:nvPr>
+            <p:ph type="title"/>
+          </p:nvPr>
+        </p:nvSpPr>
+        <p:spPr>
+          <a:xfrm>
+            <a:off x="2264833" y="2648706"/>
+            <a:ext cx="7662333" cy="1325563"/>
+          </a:xfrm>
+        </p:spPr>
+        <p:txBody>
+          <a:bodyPr>
+            <a:noAutofit/>
+          </a:bodyPr>
+          <a:lstStyle/>
+          <a:p>
+            <a:r>
+              <a:rPr lang="en-US" sz="8000" dirty="0"/>
+              <a:t>Any Questions?</a:t>
+            </a:r>
+          </a:p>
+        </p:txBody>
+      </p:sp>
+    </p:spTree>
+    <p:extLst>
+      <p:ext uri="{BB962C8B-B14F-4D97-AF65-F5344CB8AC3E}">
+        <p14:creationId xmlns:p14="http://schemas.microsoft.com/office/powerpoint/2010/main" val="30976504"/>
       </p:ext>
     </p:extLst>
   </p:cSld>
@@ -8271,12 +8337,11 @@
 </file>
 
 <file path=customXml/item1.xml><?xml version="1.0" encoding="utf-8"?>
-<?mso-contentType ?>
-<FormTemplates xmlns="http://schemas.microsoft.com/sharepoint/v3/contenttype/forms">
-  <Display>DocumentLibraryForm</Display>
-  <Edit>DocumentLibraryForm</Edit>
-  <New>DocumentLibraryForm</New>
-</FormTemplates>
+<p:properties xmlns:p="http://schemas.microsoft.com/office/2006/metadata/properties" xmlns:xsi="http://www.w3.org/2001/XMLSchema-instance" xmlns:pc="http://schemas.microsoft.com/office/infopath/2007/PartnerControls">
+  <documentManagement>
+    <_activity xmlns="7f441578-6221-4376-8ce6-60a772b8ffab" xsi:nil="true"/>
+  </documentManagement>
+</p:properties>
 </file>
 
 <file path=customXml/item2.xml><?xml version="1.0" encoding="utf-8"?>
@@ -8436,17 +8501,26 @@
 </file>
 
 <file path=customXml/item3.xml><?xml version="1.0" encoding="utf-8"?>
-<p:properties xmlns:p="http://schemas.microsoft.com/office/2006/metadata/properties" xmlns:xsi="http://www.w3.org/2001/XMLSchema-instance" xmlns:pc="http://schemas.microsoft.com/office/infopath/2007/PartnerControls">
-  <documentManagement>
-    <_activity xmlns="7f441578-6221-4376-8ce6-60a772b8ffab" xsi:nil="true"/>
-  </documentManagement>
-</p:properties>
+<?mso-contentType ?>
+<FormTemplates xmlns="http://schemas.microsoft.com/sharepoint/v3/contenttype/forms">
+  <Display>DocumentLibraryForm</Display>
+  <Edit>DocumentLibraryForm</Edit>
+  <New>DocumentLibraryForm</New>
+</FormTemplates>
 </file>
 
 <file path=customXml/itemProps1.xml><?xml version="1.0" encoding="utf-8"?>
-<ds:datastoreItem xmlns:ds="http://schemas.openxmlformats.org/officeDocument/2006/customXml" ds:itemID="{F4810B37-0855-4450-9C32-C6BC2A86203F}">
+<ds:datastoreItem xmlns:ds="http://schemas.openxmlformats.org/officeDocument/2006/customXml" ds:itemID="{6D363BA3-762C-463F-93F3-01CBC8DE6D1D}">
   <ds:schemaRefs>
-    <ds:schemaRef ds:uri="http://schemas.microsoft.com/sharepoint/v3/contenttype/forms"/>
+    <ds:schemaRef ds:uri="7f441578-6221-4376-8ce6-60a772b8ffab"/>
+    <ds:schemaRef ds:uri="http://purl.org/dc/elements/1.1/"/>
+    <ds:schemaRef ds:uri="http://purl.org/dc/dcmitype/"/>
+    <ds:schemaRef ds:uri="http://schemas.openxmlformats.org/package/2006/metadata/core-properties"/>
+    <ds:schemaRef ds:uri="http://schemas.microsoft.com/office/2006/documentManagement/types"/>
+    <ds:schemaRef ds:uri="http://purl.org/dc/terms/"/>
+    <ds:schemaRef ds:uri="http://www.w3.org/XML/1998/namespace"/>
+    <ds:schemaRef ds:uri="http://schemas.microsoft.com/office/infopath/2007/PartnerControls"/>
+    <ds:schemaRef ds:uri="http://schemas.microsoft.com/office/2006/metadata/properties"/>
   </ds:schemaRefs>
 </ds:datastoreItem>
 </file>
@@ -8470,17 +8544,9 @@
 </file>
 
 <file path=customXml/itemProps3.xml><?xml version="1.0" encoding="utf-8"?>
-<ds:datastoreItem xmlns:ds="http://schemas.openxmlformats.org/officeDocument/2006/customXml" ds:itemID="{6D363BA3-762C-463F-93F3-01CBC8DE6D1D}">
+<ds:datastoreItem xmlns:ds="http://schemas.openxmlformats.org/officeDocument/2006/customXml" ds:itemID="{F4810B37-0855-4450-9C32-C6BC2A86203F}">
   <ds:schemaRefs>
-    <ds:schemaRef ds:uri="7f441578-6221-4376-8ce6-60a772b8ffab"/>
-    <ds:schemaRef ds:uri="http://purl.org/dc/elements/1.1/"/>
-    <ds:schemaRef ds:uri="http://purl.org/dc/dcmitype/"/>
-    <ds:schemaRef ds:uri="http://schemas.openxmlformats.org/package/2006/metadata/core-properties"/>
-    <ds:schemaRef ds:uri="http://schemas.microsoft.com/office/2006/documentManagement/types"/>
-    <ds:schemaRef ds:uri="http://purl.org/dc/terms/"/>
-    <ds:schemaRef ds:uri="http://www.w3.org/XML/1998/namespace"/>
-    <ds:schemaRef ds:uri="http://schemas.microsoft.com/office/infopath/2007/PartnerControls"/>
-    <ds:schemaRef ds:uri="http://schemas.microsoft.com/office/2006/metadata/properties"/>
+    <ds:schemaRef ds:uri="http://schemas.microsoft.com/sharepoint/v3/contenttype/forms"/>
   </ds:schemaRefs>
 </ds:datastoreItem>
 </file>
</xml_diff>

<commit_message>
okay actually updating it for the last time
</commit_message>
<xml_diff>
--- a/MSAR_Findings.pptx
+++ b/MSAR_Findings.pptx
@@ -5,21 +5,26 @@
     <p:sldMasterId id="2147483660" r:id="rId4"/>
   </p:sldMasterIdLst>
   <p:notesMasterIdLst>
-    <p:notesMasterId r:id="rId17"/>
+    <p:notesMasterId r:id="rId22"/>
   </p:notesMasterIdLst>
   <p:sldIdLst>
     <p:sldId id="256" r:id="rId5"/>
     <p:sldId id="268" r:id="rId6"/>
-    <p:sldId id="259" r:id="rId7"/>
-    <p:sldId id="264" r:id="rId8"/>
-    <p:sldId id="265" r:id="rId9"/>
-    <p:sldId id="260" r:id="rId10"/>
-    <p:sldId id="263" r:id="rId11"/>
-    <p:sldId id="261" r:id="rId12"/>
-    <p:sldId id="262" r:id="rId13"/>
-    <p:sldId id="266" r:id="rId14"/>
-    <p:sldId id="267" r:id="rId15"/>
-    <p:sldId id="269" r:id="rId16"/>
+    <p:sldId id="264" r:id="rId7"/>
+    <p:sldId id="270" r:id="rId8"/>
+    <p:sldId id="271" r:id="rId9"/>
+    <p:sldId id="259" r:id="rId10"/>
+    <p:sldId id="265" r:id="rId11"/>
+    <p:sldId id="260" r:id="rId12"/>
+    <p:sldId id="263" r:id="rId13"/>
+    <p:sldId id="273" r:id="rId14"/>
+    <p:sldId id="261" r:id="rId15"/>
+    <p:sldId id="274" r:id="rId16"/>
+    <p:sldId id="272" r:id="rId17"/>
+    <p:sldId id="275" r:id="rId18"/>
+    <p:sldId id="266" r:id="rId19"/>
+    <p:sldId id="267" r:id="rId20"/>
+    <p:sldId id="269" r:id="rId21"/>
   </p:sldIdLst>
   <p:sldSz cx="12192000" cy="6858000"/>
   <p:notesSz cx="6858000" cy="9144000"/>
@@ -208,7 +213,7 @@
           <a:p>
             <a:fld id="{142A25F1-9CB4-574D-9A10-2031563C4788}" type="datetimeFigureOut">
               <a:rPr lang="en-US" smtClean="0"/>
-              <a:t>12/9/2025</a:t>
+              <a:t>12/10/2025</a:t>
             </a:fld>
             <a:endParaRPr lang="en-US"/>
           </a:p>
@@ -671,7 +676,7 @@
           <a:p>
             <a:fld id="{C398FABF-7BBB-4FC4-B3E3-346BCB227DD6}" type="datetimeFigureOut">
               <a:rPr lang="en-US" smtClean="0"/>
-              <a:t>12/9/2025</a:t>
+              <a:t>12/10/2025</a:t>
             </a:fld>
             <a:endParaRPr lang="en-US"/>
           </a:p>
@@ -952,7 +957,7 @@
           <a:p>
             <a:fld id="{C398FABF-7BBB-4FC4-B3E3-346BCB227DD6}" type="datetimeFigureOut">
               <a:rPr lang="en-US" smtClean="0"/>
-              <a:t>12/9/2025</a:t>
+              <a:t>12/10/2025</a:t>
             </a:fld>
             <a:endParaRPr lang="en-US"/>
           </a:p>
@@ -1144,7 +1149,7 @@
           <a:p>
             <a:fld id="{C398FABF-7BBB-4FC4-B3E3-346BCB227DD6}" type="datetimeFigureOut">
               <a:rPr lang="en-US" smtClean="0"/>
-              <a:t>12/9/2025</a:t>
+              <a:t>12/10/2025</a:t>
             </a:fld>
             <a:endParaRPr lang="en-US"/>
           </a:p>
@@ -1405,7 +1410,7 @@
           <a:p>
             <a:fld id="{C398FABF-7BBB-4FC4-B3E3-346BCB227DD6}" type="datetimeFigureOut">
               <a:rPr lang="en-US" smtClean="0"/>
-              <a:t>12/9/2025</a:t>
+              <a:t>12/10/2025</a:t>
             </a:fld>
             <a:endParaRPr lang="en-US"/>
           </a:p>
@@ -1831,7 +1836,7 @@
           <a:p>
             <a:fld id="{C398FABF-7BBB-4FC4-B3E3-346BCB227DD6}" type="datetimeFigureOut">
               <a:rPr lang="en-US" smtClean="0"/>
-              <a:t>12/9/2025</a:t>
+              <a:t>12/10/2025</a:t>
             </a:fld>
             <a:endParaRPr lang="en-US"/>
           </a:p>
@@ -2377,7 +2382,7 @@
           <a:p>
             <a:fld id="{C398FABF-7BBB-4FC4-B3E3-346BCB227DD6}" type="datetimeFigureOut">
               <a:rPr lang="en-US" smtClean="0"/>
-              <a:t>12/9/2025</a:t>
+              <a:t>12/10/2025</a:t>
             </a:fld>
             <a:endParaRPr lang="en-US"/>
           </a:p>
@@ -3208,7 +3213,7 @@
           <a:p>
             <a:fld id="{C398FABF-7BBB-4FC4-B3E3-346BCB227DD6}" type="datetimeFigureOut">
               <a:rPr lang="en-US" smtClean="0"/>
-              <a:t>12/9/2025</a:t>
+              <a:t>12/10/2025</a:t>
             </a:fld>
             <a:endParaRPr lang="en-US"/>
           </a:p>
@@ -3378,7 +3383,7 @@
           <a:p>
             <a:fld id="{C398FABF-7BBB-4FC4-B3E3-346BCB227DD6}" type="datetimeFigureOut">
               <a:rPr lang="en-US" smtClean="0"/>
-              <a:t>12/9/2025</a:t>
+              <a:t>12/10/2025</a:t>
             </a:fld>
             <a:endParaRPr lang="en-US"/>
           </a:p>
@@ -3558,7 +3563,7 @@
           <a:p>
             <a:fld id="{C398FABF-7BBB-4FC4-B3E3-346BCB227DD6}" type="datetimeFigureOut">
               <a:rPr lang="en-US" smtClean="0"/>
-              <a:t>12/9/2025</a:t>
+              <a:t>12/10/2025</a:t>
             </a:fld>
             <a:endParaRPr lang="en-US"/>
           </a:p>
@@ -3728,7 +3733,7 @@
           <a:p>
             <a:fld id="{C398FABF-7BBB-4FC4-B3E3-346BCB227DD6}" type="datetimeFigureOut">
               <a:rPr lang="en-US" smtClean="0"/>
-              <a:t>12/9/2025</a:t>
+              <a:t>12/10/2025</a:t>
             </a:fld>
             <a:endParaRPr lang="en-US"/>
           </a:p>
@@ -3985,7 +3990,7 @@
           <a:p>
             <a:fld id="{C398FABF-7BBB-4FC4-B3E3-346BCB227DD6}" type="datetimeFigureOut">
               <a:rPr lang="en-US" smtClean="0"/>
-              <a:t>12/9/2025</a:t>
+              <a:t>12/10/2025</a:t>
             </a:fld>
             <a:endParaRPr lang="en-US"/>
           </a:p>
@@ -4217,7 +4222,7 @@
           <a:p>
             <a:fld id="{C398FABF-7BBB-4FC4-B3E3-346BCB227DD6}" type="datetimeFigureOut">
               <a:rPr lang="en-US" smtClean="0"/>
-              <a:t>12/9/2025</a:t>
+              <a:t>12/10/2025</a:t>
             </a:fld>
             <a:endParaRPr lang="en-US"/>
           </a:p>
@@ -4610,7 +4615,7 @@
           <a:p>
             <a:fld id="{C398FABF-7BBB-4FC4-B3E3-346BCB227DD6}" type="datetimeFigureOut">
               <a:rPr lang="en-US" smtClean="0"/>
-              <a:t>12/9/2025</a:t>
+              <a:t>12/10/2025</a:t>
             </a:fld>
             <a:endParaRPr lang="en-US"/>
           </a:p>
@@ -4728,7 +4733,7 @@
           <a:p>
             <a:fld id="{C398FABF-7BBB-4FC4-B3E3-346BCB227DD6}" type="datetimeFigureOut">
               <a:rPr lang="en-US" smtClean="0"/>
-              <a:t>12/9/2025</a:t>
+              <a:t>12/10/2025</a:t>
             </a:fld>
             <a:endParaRPr lang="en-US"/>
           </a:p>
@@ -4823,7 +4828,7 @@
           <a:p>
             <a:fld id="{C398FABF-7BBB-4FC4-B3E3-346BCB227DD6}" type="datetimeFigureOut">
               <a:rPr lang="en-US" smtClean="0"/>
-              <a:t>12/9/2025</a:t>
+              <a:t>12/10/2025</a:t>
             </a:fld>
             <a:endParaRPr lang="en-US"/>
           </a:p>
@@ -5096,7 +5101,7 @@
           <a:p>
             <a:fld id="{C398FABF-7BBB-4FC4-B3E3-346BCB227DD6}" type="datetimeFigureOut">
               <a:rPr lang="en-US" smtClean="0"/>
-              <a:t>12/9/2025</a:t>
+              <a:t>12/10/2025</a:t>
             </a:fld>
             <a:endParaRPr lang="en-US"/>
           </a:p>
@@ -5377,7 +5382,7 @@
           <a:p>
             <a:fld id="{C398FABF-7BBB-4FC4-B3E3-346BCB227DD6}" type="datetimeFigureOut">
               <a:rPr lang="en-US" smtClean="0"/>
-              <a:t>12/9/2025</a:t>
+              <a:t>12/10/2025</a:t>
             </a:fld>
             <a:endParaRPr lang="en-US"/>
           </a:p>
@@ -5617,7 +5622,7 @@
           <a:p>
             <a:fld id="{C398FABF-7BBB-4FC4-B3E3-346BCB227DD6}" type="datetimeFigureOut">
               <a:rPr lang="en-US" smtClean="0"/>
-              <a:t>12/9/2025</a:t>
+              <a:t>12/10/2025</a:t>
             </a:fld>
             <a:endParaRPr lang="en-US"/>
           </a:p>
@@ -6251,6 +6256,20 @@
 <file path=ppt/slides/slide10.xml><?xml version="1.0" encoding="utf-8"?>
 <p:sld xmlns:a="http://schemas.openxmlformats.org/drawingml/2006/main" xmlns:r="http://schemas.openxmlformats.org/officeDocument/2006/relationships" xmlns:p="http://schemas.openxmlformats.org/presentationml/2006/main">
   <p:cSld>
+    <p:bg>
+      <p:bgPr>
+        <a:blipFill dpi="0" rotWithShape="1">
+          <a:blip r:embed="rId2">
+            <a:lum/>
+          </a:blip>
+          <a:srcRect/>
+          <a:stretch>
+            <a:fillRect/>
+          </a:stretch>
+        </a:blipFill>
+        <a:effectLst/>
+      </p:bgPr>
+    </p:bg>
     <p:spTree>
       <p:nvGrpSpPr>
         <p:cNvPr id="1" name=""/>
@@ -6267,118 +6286,73 @@
       </p:grpSpPr>
       <p:sp>
         <p:nvSpPr>
-          <p:cNvPr id="2" name="Title 1">
+          <p:cNvPr id="7" name="TextBox 6">
             <a:extLst>
               <a:ext uri="{FF2B5EF4-FFF2-40B4-BE49-F238E27FC236}">
-                <a16:creationId xmlns:a16="http://schemas.microsoft.com/office/drawing/2014/main" id="{2CFD0EA6-E7C7-0A1F-1078-0E13B44D29C4}"/>
+                <a16:creationId xmlns:a16="http://schemas.microsoft.com/office/drawing/2014/main" id="{FEFF203B-1EA8-FB32-F7E2-A7F60FD872D6}"/>
               </a:ext>
             </a:extLst>
           </p:cNvPr>
-          <p:cNvSpPr>
-            <a:spLocks noGrp="1"/>
-          </p:cNvSpPr>
-          <p:nvPr>
-            <p:ph type="title"/>
-          </p:nvPr>
-        </p:nvSpPr>
-        <p:spPr/>
-        <p:txBody>
-          <a:bodyPr/>
-          <a:lstStyle/>
-          <a:p>
-            <a:r>
-              <a:rPr lang="en-US" dirty="0"/>
-              <a:t>Data Outputs </a:t>
-            </a:r>
-          </a:p>
-        </p:txBody>
-      </p:sp>
-      <p:sp>
-        <p:nvSpPr>
-          <p:cNvPr id="3" name="Content Placeholder 2">
+          <p:cNvSpPr txBox="1"/>
+          <p:nvPr/>
+        </p:nvSpPr>
+        <p:spPr>
+          <a:xfrm>
+            <a:off x="1896533" y="338666"/>
+            <a:ext cx="8176381" cy="646331"/>
+          </a:xfrm>
+          <a:prstGeom prst="rect">
+            <a:avLst/>
+          </a:prstGeom>
+          <a:noFill/>
+        </p:spPr>
+        <p:txBody>
+          <a:bodyPr wrap="square" rtlCol="0">
+            <a:spAutoFit/>
+          </a:bodyPr>
+          <a:lstStyle/>
+          <a:p>
+            <a:r>
+              <a:rPr lang="en-US" sz="3600" dirty="0"/>
+              <a:t>Visualizations </a:t>
+            </a:r>
+          </a:p>
+        </p:txBody>
+      </p:sp>
+      <p:pic>
+        <p:nvPicPr>
+          <p:cNvPr id="10" name="Picture 9" descr="A map of the united states&#10;&#10;AI-generated content may be incorrect.">
             <a:extLst>
               <a:ext uri="{FF2B5EF4-FFF2-40B4-BE49-F238E27FC236}">
-                <a16:creationId xmlns:a16="http://schemas.microsoft.com/office/drawing/2014/main" id="{24DD5EA6-3F36-36EE-E064-A0556508205F}"/>
+                <a16:creationId xmlns:a16="http://schemas.microsoft.com/office/drawing/2014/main" id="{8585DDA7-2D35-F6E6-F7A8-0DC25657CB73}"/>
               </a:ext>
             </a:extLst>
           </p:cNvPr>
-          <p:cNvSpPr>
-            <a:spLocks noGrp="1"/>
-          </p:cNvSpPr>
-          <p:nvPr>
-            <p:ph idx="1"/>
-          </p:nvPr>
-        </p:nvSpPr>
-        <p:spPr/>
-        <p:txBody>
-          <a:bodyPr>
-            <a:normAutofit/>
-          </a:bodyPr>
-          <a:lstStyle/>
-          <a:p>
-            <a:r>
-              <a:rPr lang="en-US" dirty="0"/>
-              <a:t>Did more specific categorization based on the class column</a:t>
-            </a:r>
-          </a:p>
-          <a:p>
-            <a:pPr lvl="1"/>
-            <a:endParaRPr lang="en-US" dirty="0"/>
-          </a:p>
-          <a:p>
-            <a:r>
-              <a:rPr lang="en-US" dirty="0"/>
-              <a:t>Data stored as</a:t>
-            </a:r>
-          </a:p>
-          <a:p>
-            <a:pPr lvl="1"/>
-            <a:r>
-              <a:rPr lang="en-US" dirty="0"/>
-              <a:t>Excel file(s)</a:t>
-            </a:r>
-          </a:p>
-          <a:p>
-            <a:pPr lvl="2"/>
-            <a:r>
-              <a:rPr lang="en-US" dirty="0"/>
-              <a:t>data_table.xlsx – has the raw data + some extra filtered tables</a:t>
-            </a:r>
-          </a:p>
-          <a:p>
-            <a:pPr lvl="2"/>
-            <a:r>
-              <a:rPr lang="en-US" dirty="0"/>
-              <a:t>unique_courses.xlsx – counts of each unique course</a:t>
-            </a:r>
-          </a:p>
-          <a:p>
-            <a:pPr lvl="1"/>
-            <a:r>
-              <a:rPr lang="en-US" dirty="0"/>
-              <a:t>CSV files</a:t>
-            </a:r>
-          </a:p>
-          <a:p>
-            <a:pPr lvl="2"/>
-            <a:r>
-              <a:rPr lang="en-US" dirty="0"/>
-              <a:t>MSAR_table.csv – raw data</a:t>
-            </a:r>
-          </a:p>
-          <a:p>
-            <a:pPr lvl="2"/>
-            <a:r>
-              <a:rPr lang="en-US" dirty="0"/>
-              <a:t>edited_MSAR_table.csv – raw data w/ edited class columns to be more specific</a:t>
-            </a:r>
-          </a:p>
-        </p:txBody>
-      </p:sp>
+          <p:cNvPicPr>
+            <a:picLocks noChangeAspect="1"/>
+          </p:cNvPicPr>
+          <p:nvPr/>
+        </p:nvPicPr>
+        <p:blipFill>
+          <a:blip r:embed="rId3"/>
+          <a:stretch>
+            <a:fillRect/>
+          </a:stretch>
+        </p:blipFill>
+        <p:spPr>
+          <a:xfrm>
+            <a:off x="1812834" y="1252191"/>
+            <a:ext cx="8176381" cy="4810499"/>
+          </a:xfrm>
+          <a:prstGeom prst="rect">
+            <a:avLst/>
+          </a:prstGeom>
+        </p:spPr>
+      </p:pic>
     </p:spTree>
     <p:extLst>
       <p:ext uri="{BB962C8B-B14F-4D97-AF65-F5344CB8AC3E}">
-        <p14:creationId xmlns:p14="http://schemas.microsoft.com/office/powerpoint/2010/main" val="935698686"/>
+        <p14:creationId xmlns:p14="http://schemas.microsoft.com/office/powerpoint/2010/main" val="3081215684"/>
       </p:ext>
     </p:extLst>
   </p:cSld>
@@ -6389,6 +6363,161 @@
 </file>
 
 <file path=ppt/slides/slide11.xml><?xml version="1.0" encoding="utf-8"?>
+<p:sld xmlns:a="http://schemas.openxmlformats.org/drawingml/2006/main" xmlns:r="http://schemas.openxmlformats.org/officeDocument/2006/relationships" xmlns:p="http://schemas.openxmlformats.org/presentationml/2006/main">
+  <p:cSld>
+    <p:bg>
+      <p:bgPr>
+        <a:blipFill dpi="0" rotWithShape="1">
+          <a:blip r:embed="rId2">
+            <a:lum/>
+          </a:blip>
+          <a:srcRect/>
+          <a:stretch>
+            <a:fillRect/>
+          </a:stretch>
+        </a:blipFill>
+        <a:effectLst/>
+      </p:bgPr>
+    </p:bg>
+    <p:spTree>
+      <p:nvGrpSpPr>
+        <p:cNvPr id="1" name=""/>
+        <p:cNvGrpSpPr/>
+        <p:nvPr/>
+      </p:nvGrpSpPr>
+      <p:grpSpPr>
+        <a:xfrm>
+          <a:off x="0" y="0"/>
+          <a:ext cx="0" cy="0"/>
+          <a:chOff x="0" y="0"/>
+          <a:chExt cx="0" cy="0"/>
+        </a:xfrm>
+      </p:grpSpPr>
+      <p:pic>
+        <p:nvPicPr>
+          <p:cNvPr id="5" name="Picture 4" descr="A map of the united states of america&#10;&#10;AI-generated content may be incorrect.">
+            <a:extLst>
+              <a:ext uri="{FF2B5EF4-FFF2-40B4-BE49-F238E27FC236}">
+                <a16:creationId xmlns:a16="http://schemas.microsoft.com/office/drawing/2014/main" id="{001E51D7-A3F9-5937-38A1-3E9BE509AE90}"/>
+              </a:ext>
+            </a:extLst>
+          </p:cNvPr>
+          <p:cNvPicPr>
+            <a:picLocks noChangeAspect="1"/>
+          </p:cNvPicPr>
+          <p:nvPr/>
+        </p:nvPicPr>
+        <p:blipFill>
+          <a:blip r:embed="rId3"/>
+          <a:stretch>
+            <a:fillRect/>
+          </a:stretch>
+        </p:blipFill>
+        <p:spPr>
+          <a:xfrm>
+            <a:off x="2329146" y="1103544"/>
+            <a:ext cx="7533708" cy="4650912"/>
+          </a:xfrm>
+          <a:prstGeom prst="rect">
+            <a:avLst/>
+          </a:prstGeom>
+        </p:spPr>
+      </p:pic>
+    </p:spTree>
+    <p:extLst>
+      <p:ext uri="{BB962C8B-B14F-4D97-AF65-F5344CB8AC3E}">
+        <p14:creationId xmlns:p14="http://schemas.microsoft.com/office/powerpoint/2010/main" val="3007140999"/>
+      </p:ext>
+    </p:extLst>
+  </p:cSld>
+  <p:clrMapOvr>
+    <a:masterClrMapping/>
+  </p:clrMapOvr>
+</p:sld>
+</file>
+
+<file path=ppt/slides/slide12.xml><?xml version="1.0" encoding="utf-8"?>
+<p:sld xmlns:a="http://schemas.openxmlformats.org/drawingml/2006/main" xmlns:r="http://schemas.openxmlformats.org/officeDocument/2006/relationships" xmlns:p="http://schemas.openxmlformats.org/presentationml/2006/main">
+  <p:cSld>
+    <p:bg>
+      <p:bgPr>
+        <a:blipFill dpi="0" rotWithShape="1">
+          <a:blip r:embed="rId2">
+            <a:lum/>
+          </a:blip>
+          <a:srcRect/>
+          <a:stretch>
+            <a:fillRect/>
+          </a:stretch>
+        </a:blipFill>
+        <a:effectLst/>
+      </p:bgPr>
+    </p:bg>
+    <p:spTree>
+      <p:nvGrpSpPr>
+        <p:cNvPr id="1" name=""/>
+        <p:cNvGrpSpPr/>
+        <p:nvPr/>
+      </p:nvGrpSpPr>
+      <p:grpSpPr>
+        <a:xfrm>
+          <a:off x="0" y="0"/>
+          <a:ext cx="0" cy="0"/>
+          <a:chOff x="0" y="0"/>
+          <a:chExt cx="0" cy="0"/>
+        </a:xfrm>
+      </p:grpSpPr>
+      <p:pic>
+        <p:nvPicPr>
+          <p:cNvPr id="4" name="Picture 3" descr="A map of the united states&#10;&#10;AI-generated content may be incorrect.">
+            <a:extLst>
+              <a:ext uri="{FF2B5EF4-FFF2-40B4-BE49-F238E27FC236}">
+                <a16:creationId xmlns:a16="http://schemas.microsoft.com/office/drawing/2014/main" id="{A8C4FEF8-64D0-3D3C-F9BE-700CB4B8E2B0}"/>
+              </a:ext>
+            </a:extLst>
+          </p:cNvPr>
+          <p:cNvPicPr>
+            <a:picLocks noChangeAspect="1"/>
+          </p:cNvPicPr>
+          <p:nvPr/>
+        </p:nvPicPr>
+        <p:blipFill>
+          <a:blip r:embed="rId3"/>
+          <a:stretch>
+            <a:fillRect/>
+          </a:stretch>
+        </p:blipFill>
+        <p:spPr>
+          <a:xfrm>
+            <a:off x="2048360" y="943649"/>
+            <a:ext cx="8115431" cy="4970702"/>
+          </a:xfrm>
+          <a:prstGeom prst="rect">
+            <a:avLst/>
+          </a:prstGeom>
+          <a:ln w="190500" cap="flat" cmpd="thinThick">
+            <a:solidFill>
+              <a:srgbClr val="FFFFFF"/>
+            </a:solidFill>
+            <a:prstDash val="solid"/>
+            <a:round/>
+          </a:ln>
+        </p:spPr>
+      </p:pic>
+    </p:spTree>
+    <p:extLst>
+      <p:ext uri="{BB962C8B-B14F-4D97-AF65-F5344CB8AC3E}">
+        <p14:creationId xmlns:p14="http://schemas.microsoft.com/office/powerpoint/2010/main" val="3440342606"/>
+      </p:ext>
+    </p:extLst>
+  </p:cSld>
+  <p:clrMapOvr>
+    <a:masterClrMapping/>
+  </p:clrMapOvr>
+</p:sld>
+</file>
+
+<file path=ppt/slides/slide13.xml><?xml version="1.0" encoding="utf-8"?>
 <p:sld xmlns:a="http://schemas.openxmlformats.org/drawingml/2006/main" xmlns:r="http://schemas.openxmlformats.org/officeDocument/2006/relationships" xmlns:p="http://schemas.openxmlformats.org/presentationml/2006/main">
   <p:cSld>
     <p:spTree>
@@ -6410,7 +6539,7 @@
           <p:cNvPr id="2" name="Title 1">
             <a:extLst>
               <a:ext uri="{FF2B5EF4-FFF2-40B4-BE49-F238E27FC236}">
-                <a16:creationId xmlns:a16="http://schemas.microsoft.com/office/drawing/2014/main" id="{0632628C-4BBF-0022-6B38-37D5A6B3E9AE}"/>
+                <a16:creationId xmlns:a16="http://schemas.microsoft.com/office/drawing/2014/main" id="{C5FF799E-A007-6F57-FEF4-B3E0A6CCD626}"/>
               </a:ext>
             </a:extLst>
           </p:cNvPr>
@@ -6428,7 +6557,7 @@
           <a:p>
             <a:r>
               <a:rPr lang="en-US" dirty="0"/>
-              <a:t>Data Future Directions</a:t>
+              <a:t>Key Insights and Findings </a:t>
             </a:r>
           </a:p>
         </p:txBody>
@@ -6438,7 +6567,7 @@
           <p:cNvPr id="3" name="Content Placeholder 2">
             <a:extLst>
               <a:ext uri="{FF2B5EF4-FFF2-40B4-BE49-F238E27FC236}">
-                <a16:creationId xmlns:a16="http://schemas.microsoft.com/office/drawing/2014/main" id="{EB950213-EEE2-7F32-2408-8987A6541B35}"/>
+                <a16:creationId xmlns:a16="http://schemas.microsoft.com/office/drawing/2014/main" id="{4090840F-93D1-708E-ABC6-12202785ABAB}"/>
               </a:ext>
             </a:extLst>
           </p:cNvPr>
@@ -6456,30 +6585,27 @@
           <a:p>
             <a:r>
               <a:rPr lang="en-US" dirty="0"/>
-              <a:t>We can look at the Required or Recommended Column</a:t>
+              <a:t>We can see that for online biochemistry credit, the ratio is lower in the East coast</a:t>
             </a:r>
           </a:p>
           <a:p>
             <a:r>
               <a:rPr lang="en-US" dirty="0"/>
-              <a:t>We can join a data set containing the median MCAT score accepted</a:t>
+              <a:t>There are many states in the Midwest that do not have any medical schools that accept both online and community college biochemistry credit</a:t>
             </a:r>
           </a:p>
           <a:p>
             <a:r>
               <a:rPr lang="en-US" dirty="0"/>
-              <a:t>Do medical schools who accept AP credit for a class also accept AP credit for another class?</a:t>
-            </a:r>
-          </a:p>
-          <a:p>
-            <a:endParaRPr lang="en-US" dirty="0"/>
+              <a:t>The general ratios of CC biochemistry credit is generally higher than online course biochemistry credit</a:t>
+            </a:r>
           </a:p>
         </p:txBody>
       </p:sp>
     </p:spTree>
     <p:extLst>
       <p:ext uri="{BB962C8B-B14F-4D97-AF65-F5344CB8AC3E}">
-        <p14:creationId xmlns:p14="http://schemas.microsoft.com/office/powerpoint/2010/main" val="517600751"/>
+        <p14:creationId xmlns:p14="http://schemas.microsoft.com/office/powerpoint/2010/main" val="642748241"/>
       </p:ext>
     </p:extLst>
   </p:cSld>
@@ -6489,7 +6615,7 @@
 </p:sld>
 </file>
 
-<file path=ppt/slides/slide12.xml><?xml version="1.0" encoding="utf-8"?>
+<file path=ppt/slides/slide14.xml><?xml version="1.0" encoding="utf-8"?>
 <p:sld xmlns:a="http://schemas.openxmlformats.org/drawingml/2006/main" xmlns:r="http://schemas.openxmlformats.org/officeDocument/2006/relationships" xmlns:p="http://schemas.openxmlformats.org/presentationml/2006/main">
   <p:cSld>
     <p:spTree>
@@ -6511,6 +6637,333 @@
           <p:cNvPr id="2" name="Title 1">
             <a:extLst>
               <a:ext uri="{FF2B5EF4-FFF2-40B4-BE49-F238E27FC236}">
+                <a16:creationId xmlns:a16="http://schemas.microsoft.com/office/drawing/2014/main" id="{8B67690A-4E03-DE14-74E2-4EE8F8DED31C}"/>
+              </a:ext>
+            </a:extLst>
+          </p:cNvPr>
+          <p:cNvSpPr>
+            <a:spLocks noGrp="1"/>
+          </p:cNvSpPr>
+          <p:nvPr>
+            <p:ph type="title"/>
+          </p:nvPr>
+        </p:nvSpPr>
+        <p:spPr/>
+        <p:txBody>
+          <a:bodyPr/>
+          <a:lstStyle/>
+          <a:p>
+            <a:r>
+              <a:rPr lang="en-US" dirty="0"/>
+              <a:t>Conclusion</a:t>
+            </a:r>
+          </a:p>
+        </p:txBody>
+      </p:sp>
+      <p:sp>
+        <p:nvSpPr>
+          <p:cNvPr id="3" name="Content Placeholder 2">
+            <a:extLst>
+              <a:ext uri="{FF2B5EF4-FFF2-40B4-BE49-F238E27FC236}">
+                <a16:creationId xmlns:a16="http://schemas.microsoft.com/office/drawing/2014/main" id="{ED736301-BDDE-0130-1D01-6DE6B90DF2F6}"/>
+              </a:ext>
+            </a:extLst>
+          </p:cNvPr>
+          <p:cNvSpPr>
+            <a:spLocks noGrp="1"/>
+          </p:cNvSpPr>
+          <p:nvPr>
+            <p:ph idx="1"/>
+          </p:nvPr>
+        </p:nvSpPr>
+        <p:spPr/>
+        <p:txBody>
+          <a:bodyPr/>
+          <a:lstStyle/>
+          <a:p>
+            <a:r>
+              <a:rPr lang="en-US" dirty="0"/>
+              <a:t>Community College credit is generally more accepted for college credit compared to online credit</a:t>
+            </a:r>
+          </a:p>
+          <a:p>
+            <a:r>
+              <a:rPr lang="en-US" dirty="0"/>
+              <a:t>There exists a regional difference, students living in the Midwest does not have as many opportunities compared to students living in the East coast</a:t>
+            </a:r>
+          </a:p>
+        </p:txBody>
+      </p:sp>
+    </p:spTree>
+    <p:extLst>
+      <p:ext uri="{BB962C8B-B14F-4D97-AF65-F5344CB8AC3E}">
+        <p14:creationId xmlns:p14="http://schemas.microsoft.com/office/powerpoint/2010/main" val="3038813963"/>
+      </p:ext>
+    </p:extLst>
+  </p:cSld>
+  <p:clrMapOvr>
+    <a:masterClrMapping/>
+  </p:clrMapOvr>
+</p:sld>
+</file>
+
+<file path=ppt/slides/slide15.xml><?xml version="1.0" encoding="utf-8"?>
+<p:sld xmlns:a="http://schemas.openxmlformats.org/drawingml/2006/main" xmlns:r="http://schemas.openxmlformats.org/officeDocument/2006/relationships" xmlns:p="http://schemas.openxmlformats.org/presentationml/2006/main">
+  <p:cSld>
+    <p:spTree>
+      <p:nvGrpSpPr>
+        <p:cNvPr id="1" name=""/>
+        <p:cNvGrpSpPr/>
+        <p:nvPr/>
+      </p:nvGrpSpPr>
+      <p:grpSpPr>
+        <a:xfrm>
+          <a:off x="0" y="0"/>
+          <a:ext cx="0" cy="0"/>
+          <a:chOff x="0" y="0"/>
+          <a:chExt cx="0" cy="0"/>
+        </a:xfrm>
+      </p:grpSpPr>
+      <p:sp>
+        <p:nvSpPr>
+          <p:cNvPr id="2" name="Title 1">
+            <a:extLst>
+              <a:ext uri="{FF2B5EF4-FFF2-40B4-BE49-F238E27FC236}">
+                <a16:creationId xmlns:a16="http://schemas.microsoft.com/office/drawing/2014/main" id="{2CFD0EA6-E7C7-0A1F-1078-0E13B44D29C4}"/>
+              </a:ext>
+            </a:extLst>
+          </p:cNvPr>
+          <p:cNvSpPr>
+            <a:spLocks noGrp="1"/>
+          </p:cNvSpPr>
+          <p:nvPr>
+            <p:ph type="title"/>
+          </p:nvPr>
+        </p:nvSpPr>
+        <p:spPr/>
+        <p:txBody>
+          <a:bodyPr/>
+          <a:lstStyle/>
+          <a:p>
+            <a:r>
+              <a:rPr lang="en-US" dirty="0"/>
+              <a:t>Data Outputs </a:t>
+            </a:r>
+          </a:p>
+        </p:txBody>
+      </p:sp>
+      <p:sp>
+        <p:nvSpPr>
+          <p:cNvPr id="3" name="Content Placeholder 2">
+            <a:extLst>
+              <a:ext uri="{FF2B5EF4-FFF2-40B4-BE49-F238E27FC236}">
+                <a16:creationId xmlns:a16="http://schemas.microsoft.com/office/drawing/2014/main" id="{24DD5EA6-3F36-36EE-E064-A0556508205F}"/>
+              </a:ext>
+            </a:extLst>
+          </p:cNvPr>
+          <p:cNvSpPr>
+            <a:spLocks noGrp="1"/>
+          </p:cNvSpPr>
+          <p:nvPr>
+            <p:ph idx="1"/>
+          </p:nvPr>
+        </p:nvSpPr>
+        <p:spPr/>
+        <p:txBody>
+          <a:bodyPr>
+            <a:normAutofit/>
+          </a:bodyPr>
+          <a:lstStyle/>
+          <a:p>
+            <a:r>
+              <a:rPr lang="en-US" dirty="0"/>
+              <a:t>Data stored as</a:t>
+            </a:r>
+          </a:p>
+          <a:p>
+            <a:pPr lvl="1"/>
+            <a:r>
+              <a:rPr lang="en-US" dirty="0"/>
+              <a:t>Excel file(s)</a:t>
+            </a:r>
+          </a:p>
+          <a:p>
+            <a:pPr lvl="2"/>
+            <a:r>
+              <a:rPr lang="en-US" dirty="0"/>
+              <a:t>data_table.xlsx – has the raw data + some extra filtered tables</a:t>
+            </a:r>
+          </a:p>
+          <a:p>
+            <a:pPr lvl="2"/>
+            <a:r>
+              <a:rPr lang="en-US" dirty="0"/>
+              <a:t>unique_courses.xlsx – counts of each unique course</a:t>
+            </a:r>
+          </a:p>
+          <a:p>
+            <a:pPr lvl="1"/>
+            <a:r>
+              <a:rPr lang="en-US" dirty="0"/>
+              <a:t>CSV files</a:t>
+            </a:r>
+          </a:p>
+          <a:p>
+            <a:pPr lvl="2"/>
+            <a:r>
+              <a:rPr lang="en-US" dirty="0"/>
+              <a:t>MSAR_table.csv – raw data</a:t>
+            </a:r>
+          </a:p>
+          <a:p>
+            <a:pPr lvl="2"/>
+            <a:r>
+              <a:rPr lang="en-US" dirty="0"/>
+              <a:t>edited_MSAR_table.csv – raw data w/ edited class columns to be more specific</a:t>
+            </a:r>
+          </a:p>
+        </p:txBody>
+      </p:sp>
+    </p:spTree>
+    <p:extLst>
+      <p:ext uri="{BB962C8B-B14F-4D97-AF65-F5344CB8AC3E}">
+        <p14:creationId xmlns:p14="http://schemas.microsoft.com/office/powerpoint/2010/main" val="935698686"/>
+      </p:ext>
+    </p:extLst>
+  </p:cSld>
+  <p:clrMapOvr>
+    <a:masterClrMapping/>
+  </p:clrMapOvr>
+</p:sld>
+</file>
+
+<file path=ppt/slides/slide16.xml><?xml version="1.0" encoding="utf-8"?>
+<p:sld xmlns:a="http://schemas.openxmlformats.org/drawingml/2006/main" xmlns:r="http://schemas.openxmlformats.org/officeDocument/2006/relationships" xmlns:p="http://schemas.openxmlformats.org/presentationml/2006/main">
+  <p:cSld>
+    <p:spTree>
+      <p:nvGrpSpPr>
+        <p:cNvPr id="1" name=""/>
+        <p:cNvGrpSpPr/>
+        <p:nvPr/>
+      </p:nvGrpSpPr>
+      <p:grpSpPr>
+        <a:xfrm>
+          <a:off x="0" y="0"/>
+          <a:ext cx="0" cy="0"/>
+          <a:chOff x="0" y="0"/>
+          <a:chExt cx="0" cy="0"/>
+        </a:xfrm>
+      </p:grpSpPr>
+      <p:sp>
+        <p:nvSpPr>
+          <p:cNvPr id="2" name="Title 1">
+            <a:extLst>
+              <a:ext uri="{FF2B5EF4-FFF2-40B4-BE49-F238E27FC236}">
+                <a16:creationId xmlns:a16="http://schemas.microsoft.com/office/drawing/2014/main" id="{0632628C-4BBF-0022-6B38-37D5A6B3E9AE}"/>
+              </a:ext>
+            </a:extLst>
+          </p:cNvPr>
+          <p:cNvSpPr>
+            <a:spLocks noGrp="1"/>
+          </p:cNvSpPr>
+          <p:nvPr>
+            <p:ph type="title"/>
+          </p:nvPr>
+        </p:nvSpPr>
+        <p:spPr/>
+        <p:txBody>
+          <a:bodyPr/>
+          <a:lstStyle/>
+          <a:p>
+            <a:r>
+              <a:rPr lang="en-US"/>
+              <a:t>What’s </a:t>
+            </a:r>
+            <a:r>
+              <a:rPr lang="en-US" dirty="0"/>
+              <a:t>next?</a:t>
+            </a:r>
+          </a:p>
+        </p:txBody>
+      </p:sp>
+      <p:sp>
+        <p:nvSpPr>
+          <p:cNvPr id="3" name="Content Placeholder 2">
+            <a:extLst>
+              <a:ext uri="{FF2B5EF4-FFF2-40B4-BE49-F238E27FC236}">
+                <a16:creationId xmlns:a16="http://schemas.microsoft.com/office/drawing/2014/main" id="{EB950213-EEE2-7F32-2408-8987A6541B35}"/>
+              </a:ext>
+            </a:extLst>
+          </p:cNvPr>
+          <p:cNvSpPr>
+            <a:spLocks noGrp="1"/>
+          </p:cNvSpPr>
+          <p:nvPr>
+            <p:ph idx="1"/>
+          </p:nvPr>
+        </p:nvSpPr>
+        <p:spPr/>
+        <p:txBody>
+          <a:bodyPr/>
+          <a:lstStyle/>
+          <a:p>
+            <a:r>
+              <a:rPr lang="en-US" dirty="0"/>
+              <a:t>We can look at the Required or Recommended Column</a:t>
+            </a:r>
+          </a:p>
+          <a:p>
+            <a:r>
+              <a:rPr lang="en-US" dirty="0"/>
+              <a:t>We can join a data set containing the median MCAT score accepted</a:t>
+            </a:r>
+          </a:p>
+          <a:p>
+            <a:r>
+              <a:rPr lang="en-US" dirty="0"/>
+              <a:t>Do medical schools who accept AP credit for a class also accept AP credit for another class?</a:t>
+            </a:r>
+          </a:p>
+          <a:p>
+            <a:endParaRPr lang="en-US" dirty="0"/>
+          </a:p>
+        </p:txBody>
+      </p:sp>
+    </p:spTree>
+    <p:extLst>
+      <p:ext uri="{BB962C8B-B14F-4D97-AF65-F5344CB8AC3E}">
+        <p14:creationId xmlns:p14="http://schemas.microsoft.com/office/powerpoint/2010/main" val="517600751"/>
+      </p:ext>
+    </p:extLst>
+  </p:cSld>
+  <p:clrMapOvr>
+    <a:masterClrMapping/>
+  </p:clrMapOvr>
+</p:sld>
+</file>
+
+<file path=ppt/slides/slide17.xml><?xml version="1.0" encoding="utf-8"?>
+<p:sld xmlns:a="http://schemas.openxmlformats.org/drawingml/2006/main" xmlns:r="http://schemas.openxmlformats.org/officeDocument/2006/relationships" xmlns:p="http://schemas.openxmlformats.org/presentationml/2006/main">
+  <p:cSld>
+    <p:spTree>
+      <p:nvGrpSpPr>
+        <p:cNvPr id="1" name=""/>
+        <p:cNvGrpSpPr/>
+        <p:nvPr/>
+      </p:nvGrpSpPr>
+      <p:grpSpPr>
+        <a:xfrm>
+          <a:off x="0" y="0"/>
+          <a:ext cx="0" cy="0"/>
+          <a:chOff x="0" y="0"/>
+          <a:chExt cx="0" cy="0"/>
+        </a:xfrm>
+      </p:grpSpPr>
+      <p:sp>
+        <p:nvSpPr>
+          <p:cNvPr id="2" name="Title 1">
+            <a:extLst>
+              <a:ext uri="{FF2B5EF4-FFF2-40B4-BE49-F238E27FC236}">
                 <a16:creationId xmlns:a16="http://schemas.microsoft.com/office/drawing/2014/main" id="{ED56849F-805A-CD0E-77D2-C28D9D91AEDD}"/>
               </a:ext>
             </a:extLst>
@@ -6524,8 +6977,8 @@
         </p:nvSpPr>
         <p:spPr>
           <a:xfrm>
-            <a:off x="2264833" y="2648706"/>
-            <a:ext cx="7662333" cy="1325563"/>
+            <a:off x="1081616" y="2766218"/>
+            <a:ext cx="10028767" cy="1325563"/>
           </a:xfrm>
         </p:spPr>
         <p:txBody>
@@ -6534,9 +6987,21 @@
           </a:bodyPr>
           <a:lstStyle/>
           <a:p>
+            <a:pPr algn="ctr"/>
             <a:r>
               <a:rPr lang="en-US" sz="8000" dirty="0"/>
-              <a:t>Any Questions?</a:t>
+              <a:t>Thank you!</a:t>
+            </a:r>
+            <a:br>
+              <a:rPr lang="en-US" sz="8000" dirty="0"/>
+            </a:br>
+            <a:r>
+              <a:rPr lang="en-US" sz="2400" dirty="0" err="1"/>
+              <a:t>Github</a:t>
+            </a:r>
+            <a:r>
+              <a:rPr lang="en-US" sz="2400" dirty="0"/>
+              <a:t> repo: https://github.com/georgephung123/MSAR_Course_Consult</a:t>
             </a:r>
           </a:p>
         </p:txBody>
@@ -6594,7 +7059,7 @@
           <a:p>
             <a:r>
               <a:rPr lang="en-US" dirty="0"/>
-              <a:t>First Steps</a:t>
+              <a:t>Introduction</a:t>
             </a:r>
           </a:p>
         </p:txBody>
@@ -6622,27 +7087,23 @@
           <a:p>
             <a:r>
               <a:rPr lang="en-US" dirty="0"/>
-              <a:t>Asked questions about the PDF</a:t>
-            </a:r>
-          </a:p>
-          <a:p>
-            <a:pPr lvl="1"/>
+              <a:t>I scrapped the Medical School Admission Requirements Report for Applicants and Advisors’ PDF file to extract the dataset and answer questions regarding online biochemistry.</a:t>
+            </a:r>
+          </a:p>
+          <a:p>
             <a:r>
               <a:rPr lang="en-US" dirty="0"/>
-              <a:t>What’s the ratio of medical schools accepting online biochemistry credit?</a:t>
+              <a:t>I asked various questions about the PDF</a:t>
             </a:r>
           </a:p>
           <a:p>
             <a:r>
               <a:rPr lang="en-US" dirty="0"/>
-              <a:t>Looked for specific pages that could potentially interfere my web scrapping program</a:t>
-            </a:r>
-          </a:p>
-          <a:p>
-            <a:r>
-              <a:rPr lang="en-US" dirty="0"/>
-              <a:t>Took notes on interesting things within the table</a:t>
-            </a:r>
+              <a:t>I took notes on interesting things within the table</a:t>
+            </a:r>
+          </a:p>
+          <a:p>
+            <a:endParaRPr lang="en-US" dirty="0"/>
           </a:p>
           <a:p>
             <a:endParaRPr lang="en-US" dirty="0"/>
@@ -6687,7 +7148,7 @@
           <p:cNvPr id="2" name="Title 1">
             <a:extLst>
               <a:ext uri="{FF2B5EF4-FFF2-40B4-BE49-F238E27FC236}">
-                <a16:creationId xmlns:a16="http://schemas.microsoft.com/office/drawing/2014/main" id="{83270BAC-F80F-A7A1-11E4-3B7494448037}"/>
+                <a16:creationId xmlns:a16="http://schemas.microsoft.com/office/drawing/2014/main" id="{A5A60825-3903-7C9D-B341-87DA7F0D08F6}"/>
               </a:ext>
             </a:extLst>
           </p:cNvPr>
@@ -6700,14 +7161,12 @@
         </p:nvSpPr>
         <p:spPr/>
         <p:txBody>
-          <a:bodyPr>
-            <a:normAutofit fontScale="90000"/>
-          </a:bodyPr>
+          <a:bodyPr/>
           <a:lstStyle/>
           <a:p>
             <a:r>
               <a:rPr lang="en-US" dirty="0"/>
-              <a:t>Various Findings/Notes within the table</a:t>
+              <a:t>Data Parsing</a:t>
             </a:r>
           </a:p>
         </p:txBody>
@@ -6717,7 +7176,7 @@
           <p:cNvPr id="3" name="Content Placeholder 2">
             <a:extLst>
               <a:ext uri="{FF2B5EF4-FFF2-40B4-BE49-F238E27FC236}">
-                <a16:creationId xmlns:a16="http://schemas.microsoft.com/office/drawing/2014/main" id="{83B8DBFF-201D-E10F-412B-6F0F90BD50D4}"/>
+                <a16:creationId xmlns:a16="http://schemas.microsoft.com/office/drawing/2014/main" id="{8E7D5F44-9E3C-EFE5-15F4-7BE4E438FA34}"/>
               </a:ext>
             </a:extLst>
           </p:cNvPr>
@@ -6728,54 +7187,111 @@
             <p:ph idx="1"/>
           </p:nvPr>
         </p:nvSpPr>
-        <p:spPr/>
+        <p:spPr>
+          <a:xfrm>
+            <a:off x="156600" y="1690688"/>
+            <a:ext cx="6062330" cy="4351338"/>
+          </a:xfrm>
+        </p:spPr>
         <p:txBody>
           <a:bodyPr>
-            <a:normAutofit fontScale="92500"/>
+            <a:normAutofit fontScale="92500" lnSpcReduction="20000"/>
           </a:bodyPr>
           <a:lstStyle/>
           <a:p>
             <a:r>
               <a:rPr lang="en-US" dirty="0"/>
-              <a:t>In the Additional Info section, a quarter refers to a 10-week “session” compared the semester where a session typically lasts for 15 weeks</a:t>
+              <a:t>The data was originally stored in PDF with tables</a:t>
             </a:r>
           </a:p>
           <a:p>
             <a:r>
               <a:rPr lang="en-US" dirty="0"/>
-              <a:t>BESS under the Class column stands for Behavioral and Social Sciences</a:t>
-            </a:r>
-          </a:p>
-          <a:p>
+              <a:t>Steps taken to parse:</a:t>
+            </a:r>
+          </a:p>
+          <a:p>
+            <a:pPr lvl="1"/>
             <a:r>
               <a:rPr lang="en-US" dirty="0"/>
-              <a:t>Some medical schools uses AMCAS to determine which courses are eligible are not</a:t>
-            </a:r>
-          </a:p>
-          <a:p>
+              <a:t>Took all images within the tables using </a:t>
+            </a:r>
+            <a:r>
+              <a:rPr lang="en-US" dirty="0" err="1"/>
+              <a:t>pdfplumber</a:t>
+            </a:r>
+            <a:endParaRPr lang="en-US" dirty="0"/>
+          </a:p>
+          <a:p>
+            <a:pPr lvl="1"/>
             <a:r>
               <a:rPr lang="en-US" dirty="0"/>
-              <a:t>Some medical schools accept online course credit, given if it was during the COVID-19 pandemic</a:t>
-            </a:r>
-          </a:p>
-          <a:p>
+              <a:t>Extracted the RGB value of each image and assigned it to a value depending on the RGB values</a:t>
+            </a:r>
+          </a:p>
+          <a:p>
+            <a:pPr lvl="1"/>
             <a:r>
               <a:rPr lang="en-US" dirty="0"/>
-              <a:t>Most schools require 1 academic year of physics, English, chemistry, and biology</a:t>
+              <a:t>Used Camelot to extract the text from the table </a:t>
             </a:r>
           </a:p>
           <a:p>
             <a:r>
               <a:rPr lang="en-US" dirty="0"/>
-              <a:t>There are also medical schools in Canada and Puerto Rico listed</a:t>
-            </a:r>
-          </a:p>
-        </p:txBody>
-      </p:sp>
+              <a:t>A key challenge was that some pages did not have a header above</a:t>
+            </a:r>
+          </a:p>
+          <a:p>
+            <a:r>
+              <a:rPr lang="en-US" dirty="0"/>
+              <a:t>Data outputted as a .csv containing its raw data and a .</a:t>
+            </a:r>
+            <a:r>
+              <a:rPr lang="en-US" dirty="0" err="1"/>
+              <a:t>xslx</a:t>
+            </a:r>
+            <a:r>
+              <a:rPr lang="en-US" dirty="0"/>
+              <a:t> with filtered data</a:t>
+            </a:r>
+          </a:p>
+        </p:txBody>
+      </p:sp>
+      <p:pic>
+        <p:nvPicPr>
+          <p:cNvPr id="5" name="Picture 4" descr="A screenshot of a computer screen&#10;&#10;AI-generated content may be incorrect.">
+            <a:extLst>
+              <a:ext uri="{FF2B5EF4-FFF2-40B4-BE49-F238E27FC236}">
+                <a16:creationId xmlns:a16="http://schemas.microsoft.com/office/drawing/2014/main" id="{6FBFDB64-695D-285D-E55D-BDED24CD11C8}"/>
+              </a:ext>
+            </a:extLst>
+          </p:cNvPr>
+          <p:cNvPicPr>
+            <a:picLocks noChangeAspect="1"/>
+          </p:cNvPicPr>
+          <p:nvPr/>
+        </p:nvPicPr>
+        <p:blipFill>
+          <a:blip r:embed="rId2"/>
+          <a:stretch>
+            <a:fillRect/>
+          </a:stretch>
+        </p:blipFill>
+        <p:spPr>
+          <a:xfrm>
+            <a:off x="6424616" y="1361722"/>
+            <a:ext cx="5610784" cy="3586422"/>
+          </a:xfrm>
+          <a:prstGeom prst="rect">
+            <a:avLst/>
+          </a:prstGeom>
+        </p:spPr>
+      </p:pic>
     </p:spTree>
     <p:extLst>
       <p:ext uri="{BB962C8B-B14F-4D97-AF65-F5344CB8AC3E}">
-        <p14:creationId xmlns:p14="http://schemas.microsoft.com/office/powerpoint/2010/main" val="1374597468"/>
+        <p14:creationId xmlns:p14="http://schemas.microsoft.com/office/powerpoint/2010/main" val="2764104211"/>
       </p:ext>
     </p:extLst>
   </p:cSld>
@@ -6807,7 +7323,7 @@
           <p:cNvPr id="2" name="Title 1">
             <a:extLst>
               <a:ext uri="{FF2B5EF4-FFF2-40B4-BE49-F238E27FC236}">
-                <a16:creationId xmlns:a16="http://schemas.microsoft.com/office/drawing/2014/main" id="{A5A60825-3903-7C9D-B341-87DA7F0D08F6}"/>
+                <a16:creationId xmlns:a16="http://schemas.microsoft.com/office/drawing/2014/main" id="{085B9DE0-DCDB-909D-E9D3-EFAA902514CA}"/>
               </a:ext>
             </a:extLst>
           </p:cNvPr>
@@ -6825,7 +7341,7 @@
           <a:p>
             <a:r>
               <a:rPr lang="en-US" dirty="0"/>
-              <a:t>Data Parsing</a:t>
+              <a:t>A look at the raw data extracted</a:t>
             </a:r>
           </a:p>
         </p:txBody>
@@ -6835,7 +7351,7 @@
           <p:cNvPr id="3" name="Content Placeholder 2">
             <a:extLst>
               <a:ext uri="{FF2B5EF4-FFF2-40B4-BE49-F238E27FC236}">
-                <a16:creationId xmlns:a16="http://schemas.microsoft.com/office/drawing/2014/main" id="{8E7D5F44-9E3C-EFE5-15F4-7BE4E438FA34}"/>
+                <a16:creationId xmlns:a16="http://schemas.microsoft.com/office/drawing/2014/main" id="{3B5993E5-9BE5-FC6D-0523-56DC0EF17FD9}"/>
               </a:ext>
             </a:extLst>
           </p:cNvPr>
@@ -6848,131 +7364,99 @@
         </p:nvSpPr>
         <p:spPr>
           <a:xfrm>
-            <a:off x="156600" y="1690688"/>
-            <a:ext cx="6062330" cy="4351338"/>
+            <a:off x="253980" y="1559530"/>
+            <a:ext cx="3427810" cy="4351338"/>
           </a:xfrm>
         </p:spPr>
         <p:txBody>
           <a:bodyPr>
-            <a:normAutofit fontScale="77500" lnSpcReduction="20000"/>
+            <a:normAutofit lnSpcReduction="10000"/>
           </a:bodyPr>
           <a:lstStyle/>
           <a:p>
             <a:r>
               <a:rPr lang="en-US" dirty="0"/>
-              <a:t>Data originally stored in PDF with tables</a:t>
-            </a:r>
-          </a:p>
-          <a:p>
+              <a:t>Column names:</a:t>
+            </a:r>
+          </a:p>
+          <a:p>
+            <a:pPr lvl="1"/>
             <a:r>
               <a:rPr lang="en-US" dirty="0"/>
-              <a:t>Steps taken to parse:</a:t>
+              <a:t>Course</a:t>
             </a:r>
           </a:p>
           <a:p>
             <a:pPr lvl="1"/>
             <a:r>
               <a:rPr lang="en-US" dirty="0"/>
-              <a:t>Took all images within the tables using pdf plumber</a:t>
+              <a:t>Class</a:t>
             </a:r>
           </a:p>
           <a:p>
             <a:pPr lvl="1"/>
             <a:r>
               <a:rPr lang="en-US" dirty="0"/>
-              <a:t>Extracted the RGB value of each image and assigned it to a value (1, 0, or -1) depending on the RGB values</a:t>
+              <a:t>Required or Recommended?</a:t>
             </a:r>
           </a:p>
           <a:p>
             <a:pPr lvl="1"/>
             <a:r>
               <a:rPr lang="en-US" dirty="0"/>
-              <a:t>Used Camelot to extract the text from the table and organized into a pandas </a:t>
-            </a:r>
-            <a:r>
-              <a:rPr lang="en-US" dirty="0" err="1"/>
-              <a:t>DataFrame</a:t>
-            </a:r>
+              <a:t>Additional Info</a:t>
+            </a:r>
+          </a:p>
+          <a:p>
+            <a:pPr lvl="1"/>
             <a:r>
               <a:rPr lang="en-US" dirty="0"/>
-              <a:t> for each page</a:t>
+              <a:t>Credit H0urs</a:t>
             </a:r>
           </a:p>
           <a:p>
             <a:pPr lvl="1"/>
             <a:r>
               <a:rPr lang="en-US" dirty="0"/>
-              <a:t>Combined the RGB value data and the </a:t>
-            </a:r>
-            <a:r>
-              <a:rPr lang="en-US" dirty="0" err="1"/>
-              <a:t>DataFrame</a:t>
-            </a:r>
+              <a:t>Lab?</a:t>
+            </a:r>
+          </a:p>
+          <a:p>
+            <a:pPr lvl="1"/>
             <a:r>
               <a:rPr lang="en-US" dirty="0"/>
-              <a:t> table</a:t>
+              <a:t>Pass/Fail</a:t>
             </a:r>
           </a:p>
           <a:p>
             <a:pPr lvl="1"/>
             <a:r>
               <a:rPr lang="en-US" dirty="0"/>
-              <a:t>Appended the </a:t>
-            </a:r>
-            <a:r>
-              <a:rPr lang="en-US" dirty="0" err="1"/>
-              <a:t>DataFrame</a:t>
-            </a:r>
+              <a:t>AP Credit</a:t>
+            </a:r>
+          </a:p>
+          <a:p>
+            <a:pPr lvl="1"/>
             <a:r>
               <a:rPr lang="en-US" dirty="0"/>
-              <a:t> per page</a:t>
+              <a:t>Online Course</a:t>
             </a:r>
           </a:p>
           <a:p>
             <a:pPr lvl="1"/>
-            <a:endParaRPr lang="en-US" dirty="0"/>
-          </a:p>
-          <a:p>
             <a:r>
               <a:rPr lang="en-US" dirty="0"/>
-              <a:t>Data outputted as a csv containing it’s raw data and a </a:t>
-            </a:r>
-            <a:r>
-              <a:rPr lang="en-US" dirty="0" err="1"/>
-              <a:t>xslx</a:t>
-            </a:r>
-            <a:r>
-              <a:rPr lang="en-US" dirty="0"/>
-              <a:t> with filtered data</a:t>
-            </a:r>
-          </a:p>
-          <a:p>
-            <a:r>
-              <a:rPr lang="en-US" dirty="0"/>
-              <a:t>Analysis was performed using pandas, </a:t>
-            </a:r>
-            <a:r>
-              <a:rPr lang="en-US" dirty="0" err="1"/>
-              <a:t>numpy</a:t>
-            </a:r>
-            <a:r>
-              <a:rPr lang="en-US" dirty="0"/>
-              <a:t>, pillow, Camelot, and </a:t>
-            </a:r>
-            <a:r>
-              <a:rPr lang="en-US" dirty="0" err="1"/>
-              <a:t>pdfplumber</a:t>
-            </a:r>
-            <a:endParaRPr lang="en-US" dirty="0"/>
+              <a:t>Community College</a:t>
+            </a:r>
           </a:p>
         </p:txBody>
       </p:sp>
       <p:pic>
         <p:nvPicPr>
-          <p:cNvPr id="8" name="Picture 7" descr="A screenshot of a computer&#10;&#10;AI-generated content may be incorrect.">
+          <p:cNvPr id="5" name="Picture 4" descr="A screenshot of a computer&#10;&#10;AI-generated content may be incorrect.">
             <a:extLst>
               <a:ext uri="{FF2B5EF4-FFF2-40B4-BE49-F238E27FC236}">
-                <a16:creationId xmlns:a16="http://schemas.microsoft.com/office/drawing/2014/main" id="{16DC6C14-AE52-8B50-7109-4EC87B163CB4}"/>
+                <a16:creationId xmlns:a16="http://schemas.microsoft.com/office/drawing/2014/main" id="{332DCA7A-F5D7-3FB8-0EDB-EA3CB7CD9972}"/>
               </a:ext>
             </a:extLst>
           </p:cNvPr>
@@ -6989,18 +7473,53 @@
         </p:blipFill>
         <p:spPr>
           <a:xfrm>
-            <a:off x="6100594" y="0"/>
-            <a:ext cx="6091406" cy="3701143"/>
+            <a:off x="5065942" y="1486637"/>
+            <a:ext cx="6961105" cy="4229573"/>
           </a:xfrm>
           <a:prstGeom prst="rect">
             <a:avLst/>
           </a:prstGeom>
         </p:spPr>
       </p:pic>
+      <p:sp>
+        <p:nvSpPr>
+          <p:cNvPr id="6" name="TextBox 5">
+            <a:extLst>
+              <a:ext uri="{FF2B5EF4-FFF2-40B4-BE49-F238E27FC236}">
+                <a16:creationId xmlns:a16="http://schemas.microsoft.com/office/drawing/2014/main" id="{5877A3B4-DB8C-C8BA-84C5-4F6CCECCDAEC}"/>
+              </a:ext>
+            </a:extLst>
+          </p:cNvPr>
+          <p:cNvSpPr txBox="1"/>
+          <p:nvPr/>
+        </p:nvSpPr>
+        <p:spPr>
+          <a:xfrm>
+            <a:off x="5534781" y="5970210"/>
+            <a:ext cx="6657219" cy="461665"/>
+          </a:xfrm>
+          <a:prstGeom prst="rect">
+            <a:avLst/>
+          </a:prstGeom>
+          <a:noFill/>
+        </p:spPr>
+        <p:txBody>
+          <a:bodyPr wrap="square" rtlCol="0">
+            <a:spAutoFit/>
+          </a:bodyPr>
+          <a:lstStyle/>
+          <a:p>
+            <a:r>
+              <a:rPr lang="en-US" sz="2400" dirty="0"/>
+              <a:t>This dataset contains 1170 rows and 12 columns</a:t>
+            </a:r>
+          </a:p>
+        </p:txBody>
+      </p:sp>
     </p:spTree>
     <p:extLst>
       <p:ext uri="{BB962C8B-B14F-4D97-AF65-F5344CB8AC3E}">
-        <p14:creationId xmlns:p14="http://schemas.microsoft.com/office/powerpoint/2010/main" val="2764104211"/>
+        <p14:creationId xmlns:p14="http://schemas.microsoft.com/office/powerpoint/2010/main" val="2567049995"/>
       </p:ext>
     </p:extLst>
   </p:cSld>
@@ -7032,6 +7551,321 @@
           <p:cNvPr id="2" name="Title 1">
             <a:extLst>
               <a:ext uri="{FF2B5EF4-FFF2-40B4-BE49-F238E27FC236}">
+                <a16:creationId xmlns:a16="http://schemas.microsoft.com/office/drawing/2014/main" id="{8DAC1BA9-6401-3BB9-70B1-8D08007CFDB6}"/>
+              </a:ext>
+            </a:extLst>
+          </p:cNvPr>
+          <p:cNvSpPr>
+            <a:spLocks noGrp="1"/>
+          </p:cNvSpPr>
+          <p:nvPr>
+            <p:ph type="title"/>
+          </p:nvPr>
+        </p:nvSpPr>
+        <p:spPr/>
+        <p:txBody>
+          <a:bodyPr/>
+          <a:lstStyle/>
+          <a:p>
+            <a:r>
+              <a:rPr lang="en-US" dirty="0"/>
+              <a:t>Data Cleaning</a:t>
+            </a:r>
+          </a:p>
+        </p:txBody>
+      </p:sp>
+      <p:pic>
+        <p:nvPicPr>
+          <p:cNvPr id="15" name="Picture 14" descr="A screenshot of a computer&#10;&#10;AI-generated content may be incorrect.">
+            <a:extLst>
+              <a:ext uri="{FF2B5EF4-FFF2-40B4-BE49-F238E27FC236}">
+                <a16:creationId xmlns:a16="http://schemas.microsoft.com/office/drawing/2014/main" id="{8C381F5E-2FC8-B449-861E-D87F2AC6BFD4}"/>
+              </a:ext>
+            </a:extLst>
+          </p:cNvPr>
+          <p:cNvPicPr>
+            <a:picLocks noChangeAspect="1"/>
+          </p:cNvPicPr>
+          <p:nvPr/>
+        </p:nvPicPr>
+        <p:blipFill>
+          <a:blip r:embed="rId2"/>
+          <a:stretch>
+            <a:fillRect/>
+          </a:stretch>
+        </p:blipFill>
+        <p:spPr>
+          <a:xfrm>
+            <a:off x="2316238" y="1878320"/>
+            <a:ext cx="6591056" cy="2492633"/>
+          </a:xfrm>
+          <a:prstGeom prst="rect">
+            <a:avLst/>
+          </a:prstGeom>
+        </p:spPr>
+      </p:pic>
+      <p:pic>
+        <p:nvPicPr>
+          <p:cNvPr id="17" name="Picture 16" descr="A screenshot of a computer&#10;&#10;AI-generated content may be incorrect.">
+            <a:extLst>
+              <a:ext uri="{FF2B5EF4-FFF2-40B4-BE49-F238E27FC236}">
+                <a16:creationId xmlns:a16="http://schemas.microsoft.com/office/drawing/2014/main" id="{D93F013F-37DD-9D14-F739-A585B17BAE47}"/>
+              </a:ext>
+            </a:extLst>
+          </p:cNvPr>
+          <p:cNvPicPr>
+            <a:picLocks noChangeAspect="1"/>
+          </p:cNvPicPr>
+          <p:nvPr/>
+        </p:nvPicPr>
+        <p:blipFill>
+          <a:blip r:embed="rId3"/>
+          <a:stretch>
+            <a:fillRect/>
+          </a:stretch>
+        </p:blipFill>
+        <p:spPr>
+          <a:xfrm>
+            <a:off x="2206503" y="4911293"/>
+            <a:ext cx="9672018" cy="1825754"/>
+          </a:xfrm>
+          <a:prstGeom prst="rect">
+            <a:avLst/>
+          </a:prstGeom>
+        </p:spPr>
+      </p:pic>
+      <p:sp>
+        <p:nvSpPr>
+          <p:cNvPr id="20" name="TextBox 19">
+            <a:extLst>
+              <a:ext uri="{FF2B5EF4-FFF2-40B4-BE49-F238E27FC236}">
+                <a16:creationId xmlns:a16="http://schemas.microsoft.com/office/drawing/2014/main" id="{19433CCE-BDA7-008C-67BF-8CE05A391AB0}"/>
+              </a:ext>
+            </a:extLst>
+          </p:cNvPr>
+          <p:cNvSpPr txBox="1"/>
+          <p:nvPr/>
+        </p:nvSpPr>
+        <p:spPr>
+          <a:xfrm>
+            <a:off x="157238" y="2247295"/>
+            <a:ext cx="4318000" cy="3970318"/>
+          </a:xfrm>
+          <a:prstGeom prst="rect">
+            <a:avLst/>
+          </a:prstGeom>
+          <a:noFill/>
+        </p:spPr>
+        <p:txBody>
+          <a:bodyPr wrap="square" rtlCol="0">
+            <a:spAutoFit/>
+          </a:bodyPr>
+          <a:lstStyle/>
+          <a:p>
+            <a:r>
+              <a:rPr lang="en-US" dirty="0"/>
+              <a:t>Before cleaning:</a:t>
+            </a:r>
+          </a:p>
+          <a:p>
+            <a:endParaRPr lang="en-US" dirty="0"/>
+          </a:p>
+          <a:p>
+            <a:endParaRPr lang="en-US" dirty="0"/>
+          </a:p>
+          <a:p>
+            <a:endParaRPr lang="en-US" dirty="0"/>
+          </a:p>
+          <a:p>
+            <a:endParaRPr lang="en-US" dirty="0"/>
+          </a:p>
+          <a:p>
+            <a:endParaRPr lang="en-US" dirty="0"/>
+          </a:p>
+          <a:p>
+            <a:endParaRPr lang="en-US" dirty="0"/>
+          </a:p>
+          <a:p>
+            <a:endParaRPr lang="en-US" dirty="0"/>
+          </a:p>
+          <a:p>
+            <a:endParaRPr lang="en-US" dirty="0"/>
+          </a:p>
+          <a:p>
+            <a:endParaRPr lang="en-US" dirty="0"/>
+          </a:p>
+          <a:p>
+            <a:endParaRPr lang="en-US" dirty="0"/>
+          </a:p>
+          <a:p>
+            <a:endParaRPr lang="en-US" dirty="0"/>
+          </a:p>
+          <a:p>
+            <a:r>
+              <a:rPr lang="en-US" dirty="0"/>
+              <a:t>After cleaning:</a:t>
+            </a:r>
+          </a:p>
+          <a:p>
+            <a:endParaRPr lang="en-US" dirty="0"/>
+          </a:p>
+        </p:txBody>
+      </p:sp>
+    </p:spTree>
+    <p:extLst>
+      <p:ext uri="{BB962C8B-B14F-4D97-AF65-F5344CB8AC3E}">
+        <p14:creationId xmlns:p14="http://schemas.microsoft.com/office/powerpoint/2010/main" val="3217066892"/>
+      </p:ext>
+    </p:extLst>
+  </p:cSld>
+  <p:clrMapOvr>
+    <a:masterClrMapping/>
+  </p:clrMapOvr>
+</p:sld>
+</file>
+
+<file path=ppt/slides/slide6.xml><?xml version="1.0" encoding="utf-8"?>
+<p:sld xmlns:a="http://schemas.openxmlformats.org/drawingml/2006/main" xmlns:r="http://schemas.openxmlformats.org/officeDocument/2006/relationships" xmlns:p="http://schemas.openxmlformats.org/presentationml/2006/main">
+  <p:cSld>
+    <p:spTree>
+      <p:nvGrpSpPr>
+        <p:cNvPr id="1" name=""/>
+        <p:cNvGrpSpPr/>
+        <p:nvPr/>
+      </p:nvGrpSpPr>
+      <p:grpSpPr>
+        <a:xfrm>
+          <a:off x="0" y="0"/>
+          <a:ext cx="0" cy="0"/>
+          <a:chOff x="0" y="0"/>
+          <a:chExt cx="0" cy="0"/>
+        </a:xfrm>
+      </p:grpSpPr>
+      <p:sp>
+        <p:nvSpPr>
+          <p:cNvPr id="2" name="Title 1">
+            <a:extLst>
+              <a:ext uri="{FF2B5EF4-FFF2-40B4-BE49-F238E27FC236}">
+                <a16:creationId xmlns:a16="http://schemas.microsoft.com/office/drawing/2014/main" id="{83270BAC-F80F-A7A1-11E4-3B7494448037}"/>
+              </a:ext>
+            </a:extLst>
+          </p:cNvPr>
+          <p:cNvSpPr>
+            <a:spLocks noGrp="1"/>
+          </p:cNvSpPr>
+          <p:nvPr>
+            <p:ph type="title"/>
+          </p:nvPr>
+        </p:nvSpPr>
+        <p:spPr/>
+        <p:txBody>
+          <a:bodyPr>
+            <a:normAutofit/>
+          </a:bodyPr>
+          <a:lstStyle/>
+          <a:p>
+            <a:r>
+              <a:rPr lang="en-US" dirty="0"/>
+              <a:t>Pre-Data Analysis findings</a:t>
+            </a:r>
+          </a:p>
+        </p:txBody>
+      </p:sp>
+      <p:sp>
+        <p:nvSpPr>
+          <p:cNvPr id="3" name="Content Placeholder 2">
+            <a:extLst>
+              <a:ext uri="{FF2B5EF4-FFF2-40B4-BE49-F238E27FC236}">
+                <a16:creationId xmlns:a16="http://schemas.microsoft.com/office/drawing/2014/main" id="{83B8DBFF-201D-E10F-412B-6F0F90BD50D4}"/>
+              </a:ext>
+            </a:extLst>
+          </p:cNvPr>
+          <p:cNvSpPr>
+            <a:spLocks noGrp="1"/>
+          </p:cNvSpPr>
+          <p:nvPr>
+            <p:ph idx="1"/>
+          </p:nvPr>
+        </p:nvSpPr>
+        <p:spPr/>
+        <p:txBody>
+          <a:bodyPr>
+            <a:normAutofit fontScale="92500" lnSpcReduction="20000"/>
+          </a:bodyPr>
+          <a:lstStyle/>
+          <a:p>
+            <a:r>
+              <a:rPr lang="en-US" dirty="0"/>
+              <a:t>In the Additional Info section, a quarter refers to a 10-week academic “session” compared the semester where a session typically lasts for 15 weeks</a:t>
+            </a:r>
+          </a:p>
+          <a:p>
+            <a:r>
+              <a:rPr lang="en-US" dirty="0"/>
+              <a:t>“BESS” under the Class column denotes Behavioral and Social Sciences coursework</a:t>
+            </a:r>
+          </a:p>
+          <a:p>
+            <a:r>
+              <a:rPr lang="en-US" dirty="0"/>
+              <a:t>Some medical schools uses AMCAS guidelines to determine which courses are eligible are not</a:t>
+            </a:r>
+          </a:p>
+          <a:p>
+            <a:r>
+              <a:rPr lang="en-US" dirty="0"/>
+              <a:t>Some medical schools accept online course credit, given if it was during the COVID-19 pandemic</a:t>
+            </a:r>
+          </a:p>
+          <a:p>
+            <a:r>
+              <a:rPr lang="en-US" dirty="0"/>
+              <a:t>Most schools require 1 academic year of physics, English, chemistry, and biology</a:t>
+            </a:r>
+          </a:p>
+          <a:p>
+            <a:r>
+              <a:rPr lang="en-US" dirty="0"/>
+              <a:t>This dataset also includes medical schools that are in Canada and Puerto Rico</a:t>
+            </a:r>
+          </a:p>
+        </p:txBody>
+      </p:sp>
+    </p:spTree>
+    <p:extLst>
+      <p:ext uri="{BB962C8B-B14F-4D97-AF65-F5344CB8AC3E}">
+        <p14:creationId xmlns:p14="http://schemas.microsoft.com/office/powerpoint/2010/main" val="1374597468"/>
+      </p:ext>
+    </p:extLst>
+  </p:cSld>
+  <p:clrMapOvr>
+    <a:masterClrMapping/>
+  </p:clrMapOvr>
+</p:sld>
+</file>
+
+<file path=ppt/slides/slide7.xml><?xml version="1.0" encoding="utf-8"?>
+<p:sld xmlns:a="http://schemas.openxmlformats.org/drawingml/2006/main" xmlns:r="http://schemas.openxmlformats.org/officeDocument/2006/relationships" xmlns:p="http://schemas.openxmlformats.org/presentationml/2006/main">
+  <p:cSld>
+    <p:spTree>
+      <p:nvGrpSpPr>
+        <p:cNvPr id="1" name=""/>
+        <p:cNvGrpSpPr/>
+        <p:nvPr/>
+      </p:nvGrpSpPr>
+      <p:grpSpPr>
+        <a:xfrm>
+          <a:off x="0" y="0"/>
+          <a:ext cx="0" cy="0"/>
+          <a:chOff x="0" y="0"/>
+          <a:chExt cx="0" cy="0"/>
+        </a:xfrm>
+      </p:grpSpPr>
+      <p:sp>
+        <p:nvSpPr>
+          <p:cNvPr id="2" name="Title 1">
+            <a:extLst>
+              <a:ext uri="{FF2B5EF4-FFF2-40B4-BE49-F238E27FC236}">
                 <a16:creationId xmlns:a16="http://schemas.microsoft.com/office/drawing/2014/main" id="{E1D27650-8765-1AEF-C2D4-351AA802A5B6}"/>
               </a:ext>
             </a:extLst>
@@ -7083,7 +7917,7 @@
           <a:p>
             <a:r>
               <a:rPr lang="en-US" dirty="0"/>
-              <a:t>Created code for the following statistics:</a:t>
+              <a:t>I created code for the following statistics:</a:t>
             </a:r>
           </a:p>
           <a:p>
@@ -7111,7 +7945,7 @@
             <a:pPr lvl="1"/>
             <a:r>
               <a:rPr lang="en-US" dirty="0"/>
-              <a:t>Did a Kruskal-Wallis test</a:t>
+              <a:t>Did a Kruskal-Wallis test on the courses</a:t>
             </a:r>
           </a:p>
         </p:txBody>
@@ -7159,7 +7993,7 @@
 </p:sld>
 </file>
 
-<file path=ppt/slides/slide6.xml><?xml version="1.0" encoding="utf-8"?>
+<file path=ppt/slides/slide8.xml><?xml version="1.0" encoding="utf-8"?>
 <p:sld xmlns:a="http://schemas.openxmlformats.org/drawingml/2006/main" xmlns:r="http://schemas.openxmlformats.org/officeDocument/2006/relationships" xmlns:p="http://schemas.openxmlformats.org/presentationml/2006/main">
   <p:cSld>
     <p:spTree>
@@ -7227,7 +8061,7 @@
           <a:p>
             <a:r>
               <a:rPr lang="en-US" dirty="0"/>
-              <a:t>Schools w/ online BCHM:</a:t>
+              <a:t>Schools with online BCHM:</a:t>
             </a:r>
           </a:p>
           <a:p>
@@ -7254,7 +8088,7 @@
           <a:p>
             <a:r>
               <a:rPr lang="en-US" dirty="0"/>
-              <a:t>Schools w/ CC BCHM:</a:t>
+              <a:t>Schools with CC BCHM:</a:t>
             </a:r>
           </a:p>
           <a:p>
@@ -7293,7 +8127,7 @@
 </p:sld>
 </file>
 
-<file path=ppt/slides/slide7.xml><?xml version="1.0" encoding="utf-8"?>
+<file path=ppt/slides/slide9.xml><?xml version="1.0" encoding="utf-8"?>
 <p:sld xmlns:a="http://schemas.openxmlformats.org/drawingml/2006/main" xmlns:r="http://schemas.openxmlformats.org/officeDocument/2006/relationships" xmlns:p="http://schemas.openxmlformats.org/presentationml/2006/main">
   <p:cSld>
     <p:spTree>
@@ -7363,7 +8197,7 @@
           <a:p>
             <a:r>
               <a:rPr lang="en-US" dirty="0"/>
-              <a:t>Schools w/ online BESS:</a:t>
+              <a:t>Schools with online BESS:</a:t>
             </a:r>
           </a:p>
           <a:p>
@@ -7390,7 +8224,7 @@
           <a:p>
             <a:r>
               <a:rPr lang="en-US" dirty="0"/>
-              <a:t>Schools w/ online BIOL:</a:t>
+              <a:t>Schools with online BIOL:</a:t>
             </a:r>
           </a:p>
           <a:p>
@@ -7417,7 +8251,7 @@
           <a:p>
             <a:r>
               <a:rPr lang="en-US" dirty="0"/>
-              <a:t>A Kruskal-Wallis test found no significant relationship between course type and medical-school acceptance ratios (p = 0.41).</a:t>
+              <a:t>A Kruskal-Wallis test found no significant relationship between course type and medical-school acceptance ratios (p = 0.41)</a:t>
             </a:r>
           </a:p>
         </p:txBody>
@@ -7426,331 +8260,6 @@
     <p:extLst>
       <p:ext uri="{BB962C8B-B14F-4D97-AF65-F5344CB8AC3E}">
         <p14:creationId xmlns:p14="http://schemas.microsoft.com/office/powerpoint/2010/main" val="2376397300"/>
-      </p:ext>
-    </p:extLst>
-  </p:cSld>
-  <p:clrMapOvr>
-    <a:masterClrMapping/>
-  </p:clrMapOvr>
-</p:sld>
-</file>
-
-<file path=ppt/slides/slide8.xml><?xml version="1.0" encoding="utf-8"?>
-<p:sld xmlns:a="http://schemas.openxmlformats.org/drawingml/2006/main" xmlns:r="http://schemas.openxmlformats.org/officeDocument/2006/relationships" xmlns:p="http://schemas.openxmlformats.org/presentationml/2006/main">
-  <p:cSld>
-    <p:bg>
-      <p:bgPr>
-        <a:blipFill dpi="0" rotWithShape="1">
-          <a:blip r:embed="rId2">
-            <a:lum/>
-          </a:blip>
-          <a:srcRect/>
-          <a:stretch>
-            <a:fillRect/>
-          </a:stretch>
-        </a:blipFill>
-        <a:effectLst/>
-      </p:bgPr>
-    </p:bg>
-    <p:spTree>
-      <p:nvGrpSpPr>
-        <p:cNvPr id="1" name=""/>
-        <p:cNvGrpSpPr/>
-        <p:nvPr/>
-      </p:nvGrpSpPr>
-      <p:grpSpPr>
-        <a:xfrm>
-          <a:off x="0" y="0"/>
-          <a:ext cx="0" cy="0"/>
-          <a:chOff x="0" y="0"/>
-          <a:chExt cx="0" cy="0"/>
-        </a:xfrm>
-      </p:grpSpPr>
-      <p:pic>
-        <p:nvPicPr>
-          <p:cNvPr id="3" name="Picture 2" descr="A map of the united states&#10;&#10;AI-generated content may be incorrect.">
-            <a:extLst>
-              <a:ext uri="{FF2B5EF4-FFF2-40B4-BE49-F238E27FC236}">
-                <a16:creationId xmlns:a16="http://schemas.microsoft.com/office/drawing/2014/main" id="{B088A653-6B86-8C1B-A9FB-2F14A3CE9CA7}"/>
-              </a:ext>
-            </a:extLst>
-          </p:cNvPr>
-          <p:cNvPicPr>
-            <a:picLocks noChangeAspect="1"/>
-          </p:cNvPicPr>
-          <p:nvPr/>
-        </p:nvPicPr>
-        <p:blipFill>
-          <a:blip r:embed="rId3"/>
-          <a:stretch>
-            <a:fillRect/>
-          </a:stretch>
-        </p:blipFill>
-        <p:spPr>
-          <a:xfrm>
-            <a:off x="2520682" y="965200"/>
-            <a:ext cx="7150635" cy="4290381"/>
-          </a:xfrm>
-          <a:prstGeom prst="rect">
-            <a:avLst/>
-          </a:prstGeom>
-          <a:ln w="190500">
-            <a:solidFill>
-              <a:srgbClr val="FFFFFF"/>
-            </a:solidFill>
-          </a:ln>
-          <a:effectLst>
-            <a:reflection blurRad="38100" stA="52000" endA="300" endPos="30000" dir="5400000" sy="-100000" algn="bl" rotWithShape="0"/>
-            <a:softEdge rad="19050"/>
-          </a:effectLst>
-        </p:spPr>
-      </p:pic>
-    </p:spTree>
-    <p:extLst>
-      <p:ext uri="{BB962C8B-B14F-4D97-AF65-F5344CB8AC3E}">
-        <p14:creationId xmlns:p14="http://schemas.microsoft.com/office/powerpoint/2010/main" val="3007140999"/>
-      </p:ext>
-    </p:extLst>
-  </p:cSld>
-  <p:clrMapOvr>
-    <a:masterClrMapping/>
-  </p:clrMapOvr>
-</p:sld>
-</file>
-
-<file path=ppt/slides/slide9.xml><?xml version="1.0" encoding="utf-8"?>
-<p:sld xmlns:a="http://schemas.openxmlformats.org/drawingml/2006/main" xmlns:r="http://schemas.openxmlformats.org/officeDocument/2006/relationships" xmlns:p="http://schemas.openxmlformats.org/presentationml/2006/main">
-  <p:cSld>
-    <p:bg>
-      <p:bgPr>
-        <a:blipFill dpi="0" rotWithShape="1">
-          <a:blip r:embed="rId2">
-            <a:lum/>
-          </a:blip>
-          <a:srcRect/>
-          <a:stretch>
-            <a:fillRect/>
-          </a:stretch>
-        </a:blipFill>
-        <a:effectLst/>
-      </p:bgPr>
-    </p:bg>
-    <p:spTree>
-      <p:nvGrpSpPr>
-        <p:cNvPr id="1" name=""/>
-        <p:cNvGrpSpPr/>
-        <p:nvPr/>
-      </p:nvGrpSpPr>
-      <p:grpSpPr>
-        <a:xfrm>
-          <a:off x="0" y="0"/>
-          <a:ext cx="0" cy="0"/>
-          <a:chOff x="0" y="0"/>
-          <a:chExt cx="0" cy="0"/>
-        </a:xfrm>
-      </p:grpSpPr>
-      <p:sp>
-        <p:nvSpPr>
-          <p:cNvPr id="7" name="Title 1">
-            <a:extLst>
-              <a:ext uri="{FF2B5EF4-FFF2-40B4-BE49-F238E27FC236}">
-                <a16:creationId xmlns:a16="http://schemas.microsoft.com/office/drawing/2014/main" id="{96F4A75A-AE6E-48E5-8C9B-62D0A953E31B}"/>
-              </a:ext>
-              <a:ext uri="{C183D7F6-B498-43B3-948B-1728B52AA6E4}">
-                <adec:decorative xmlns:adec="http://schemas.microsoft.com/office/drawing/2017/decorative" val="1"/>
-              </a:ext>
-            </a:extLst>
-          </p:cNvPr>
-          <p:cNvSpPr txBox="1">
-            <a:spLocks noGrp="1" noRot="1" noChangeAspect="1" noMove="1" noResize="1" noEditPoints="1" noAdjustHandles="1" noChangeArrowheads="1" noChangeShapeType="1" noTextEdit="1"/>
-          </p:cNvSpPr>
-          <p:nvPr>
-            <p:extLst>
-              <p:ext uri="{386F3935-93C4-4BCD-93E2-E3B085C9AB24}">
-                <p16:designElem xmlns:p16="http://schemas.microsoft.com/office/powerpoint/2015/main" val="1"/>
-              </p:ext>
-            </p:extLst>
-          </p:nvPr>
-        </p:nvSpPr>
-        <p:spPr>
-          <a:xfrm>
-            <a:off x="5277678" y="2627791"/>
-            <a:ext cx="6235148" cy="3592034"/>
-          </a:xfrm>
-          <a:prstGeom prst="rect">
-            <a:avLst/>
-          </a:prstGeom>
-        </p:spPr>
-        <p:txBody>
-          <a:bodyPr vert="horz" wrap="none" lIns="91440" tIns="45720" rIns="91440" bIns="45720" rtlCol="0" anchor="t">
-            <a:normAutofit/>
-          </a:bodyPr>
-          <a:lstStyle>
-            <a:lvl1pPr algn="r" defTabSz="914400" rtl="0" eaLnBrk="1" latinLnBrk="0" hangingPunct="1">
-              <a:lnSpc>
-                <a:spcPct val="90000"/>
-              </a:lnSpc>
-              <a:spcBef>
-                <a:spcPct val="0"/>
-              </a:spcBef>
-              <a:buNone/>
-              <a:defRPr sz="9600" b="0" kern="1200" spc="-300">
-                <a:gradFill flip="none" rotWithShape="1">
-                  <a:gsLst>
-                    <a:gs pos="32000">
-                      <a:schemeClr val="tx1">
-                        <a:lumMod val="89000"/>
-                      </a:schemeClr>
-                    </a:gs>
-                    <a:gs pos="0">
-                      <a:schemeClr val="bg1">
-                        <a:lumMod val="41000"/>
-                        <a:lumOff val="59000"/>
-                      </a:schemeClr>
-                    </a:gs>
-                    <a:gs pos="100000">
-                      <a:schemeClr val="tx2">
-                        <a:lumMod val="0"/>
-                        <a:lumOff val="100000"/>
-                      </a:schemeClr>
-                    </a:gs>
-                  </a:gsLst>
-                  <a:lin ang="8100000" scaled="1"/>
-                  <a:tileRect/>
-                </a:gradFill>
-                <a:effectLst>
-                  <a:outerShdw blurRad="469900" dist="342900" dir="5400000" sy="-20000" rotWithShape="0">
-                    <a:prstClr val="black">
-                      <a:alpha val="66000"/>
-                    </a:prstClr>
-                  </a:outerShdw>
-                </a:effectLst>
-                <a:latin typeface="+mj-lt"/>
-                <a:ea typeface="+mj-ea"/>
-                <a:cs typeface="+mj-cs"/>
-              </a:defRPr>
-            </a:lvl1pPr>
-          </a:lstStyle>
-          <a:p>
-            <a:endParaRPr lang="en-US" dirty="0">
-              <a:effectLst>
-                <a:outerShdw blurRad="469900" dist="342900" dir="5400000" sy="-20000" rotWithShape="0">
-                  <a:schemeClr val="bg1"/>
-                </a:outerShdw>
-              </a:effectLst>
-            </a:endParaRPr>
-          </a:p>
-        </p:txBody>
-      </p:sp>
-      <p:sp>
-        <p:nvSpPr>
-          <p:cNvPr id="9" name="Rounded Rectangle 18">
-            <a:extLst>
-              <a:ext uri="{FF2B5EF4-FFF2-40B4-BE49-F238E27FC236}">
-                <a16:creationId xmlns:a16="http://schemas.microsoft.com/office/drawing/2014/main" id="{5FE0DFF3-0858-4641-9E40-6BE7ACCC4F0D}"/>
-              </a:ext>
-              <a:ext uri="{C183D7F6-B498-43B3-948B-1728B52AA6E4}">
-                <adec:decorative xmlns:adec="http://schemas.microsoft.com/office/drawing/2017/decorative" val="1"/>
-              </a:ext>
-            </a:extLst>
-          </p:cNvPr>
-          <p:cNvSpPr>
-            <a:spLocks noGrp="1" noRot="1" noChangeAspect="1" noMove="1" noResize="1" noEditPoints="1" noAdjustHandles="1" noChangeArrowheads="1" noChangeShapeType="1" noTextEdit="1"/>
-          </p:cNvSpPr>
-          <p:nvPr>
-            <p:extLst>
-              <p:ext uri="{386F3935-93C4-4BCD-93E2-E3B085C9AB24}">
-                <p16:designElem xmlns:p16="http://schemas.microsoft.com/office/powerpoint/2015/main" val="1"/>
-              </p:ext>
-            </p:extLst>
-          </p:nvPr>
-        </p:nvSpPr>
-        <p:spPr>
-          <a:xfrm>
-            <a:off x="643467" y="643467"/>
-            <a:ext cx="10905070" cy="5126188"/>
-          </a:xfrm>
-          <a:prstGeom prst="roundRect">
-            <a:avLst>
-              <a:gd name="adj" fmla="val 2028"/>
-            </a:avLst>
-          </a:prstGeom>
-          <a:solidFill>
-            <a:schemeClr val="tx1"/>
-          </a:solidFill>
-          <a:ln>
-            <a:solidFill>
-              <a:schemeClr val="accent1">
-                <a:shade val="50000"/>
-              </a:schemeClr>
-            </a:solidFill>
-          </a:ln>
-          <a:effectLst>
-            <a:innerShdw blurRad="127000" dist="12700">
-              <a:prstClr val="black"/>
-            </a:innerShdw>
-            <a:reflection blurRad="6350" stA="52000" endA="300" endPos="20000" dir="5400000" sy="-100000" algn="bl" rotWithShape="0"/>
-          </a:effectLst>
-        </p:spPr>
-        <p:style>
-          <a:lnRef idx="2">
-            <a:schemeClr val="accent1">
-              <a:shade val="50000"/>
-            </a:schemeClr>
-          </a:lnRef>
-          <a:fillRef idx="1">
-            <a:schemeClr val="accent1"/>
-          </a:fillRef>
-          <a:effectRef idx="0">
-            <a:schemeClr val="accent1"/>
-          </a:effectRef>
-          <a:fontRef idx="minor">
-            <a:schemeClr val="lt1"/>
-          </a:fontRef>
-        </p:style>
-        <p:txBody>
-          <a:bodyPr rtlCol="0" anchor="ctr"/>
-          <a:lstStyle/>
-          <a:p>
-            <a:pPr algn="ctr"/>
-            <a:endParaRPr lang="en-US"/>
-          </a:p>
-        </p:txBody>
-      </p:sp>
-      <p:pic>
-        <p:nvPicPr>
-          <p:cNvPr id="2" name="Picture 1" descr="A map of the united states&#10;&#10;AI-generated content may be incorrect.">
-            <a:extLst>
-              <a:ext uri="{FF2B5EF4-FFF2-40B4-BE49-F238E27FC236}">
-                <a16:creationId xmlns:a16="http://schemas.microsoft.com/office/drawing/2014/main" id="{E7F9472D-BBF7-AEC9-CB77-3F3E0F7A4653}"/>
-              </a:ext>
-            </a:extLst>
-          </p:cNvPr>
-          <p:cNvPicPr>
-            <a:picLocks noChangeAspect="1"/>
-          </p:cNvPicPr>
-          <p:nvPr/>
-        </p:nvPicPr>
-        <p:blipFill>
-          <a:blip r:embed="rId3"/>
-          <a:stretch>
-            <a:fillRect/>
-          </a:stretch>
-        </p:blipFill>
-        <p:spPr>
-          <a:xfrm>
-            <a:off x="2197085" y="957390"/>
-            <a:ext cx="7785283" cy="4496001"/>
-          </a:xfrm>
-          <a:prstGeom prst="rect">
-            <a:avLst/>
-          </a:prstGeom>
-        </p:spPr>
-      </p:pic>
-    </p:spTree>
-    <p:extLst>
-      <p:ext uri="{BB962C8B-B14F-4D97-AF65-F5344CB8AC3E}">
-        <p14:creationId xmlns:p14="http://schemas.microsoft.com/office/powerpoint/2010/main" val="28594390"/>
       </p:ext>
     </p:extLst>
   </p:cSld>
@@ -8337,11 +8846,12 @@
 </file>
 
 <file path=customXml/item1.xml><?xml version="1.0" encoding="utf-8"?>
-<p:properties xmlns:p="http://schemas.microsoft.com/office/2006/metadata/properties" xmlns:xsi="http://www.w3.org/2001/XMLSchema-instance" xmlns:pc="http://schemas.microsoft.com/office/infopath/2007/PartnerControls">
-  <documentManagement>
-    <_activity xmlns="7f441578-6221-4376-8ce6-60a772b8ffab" xsi:nil="true"/>
-  </documentManagement>
-</p:properties>
+<?mso-contentType ?>
+<FormTemplates xmlns="http://schemas.microsoft.com/sharepoint/v3/contenttype/forms">
+  <Display>DocumentLibraryForm</Display>
+  <Edit>DocumentLibraryForm</Edit>
+  <New>DocumentLibraryForm</New>
+</FormTemplates>
 </file>
 
 <file path=customXml/item2.xml><?xml version="1.0" encoding="utf-8"?>
@@ -8501,26 +9011,17 @@
 </file>
 
 <file path=customXml/item3.xml><?xml version="1.0" encoding="utf-8"?>
-<?mso-contentType ?>
-<FormTemplates xmlns="http://schemas.microsoft.com/sharepoint/v3/contenttype/forms">
-  <Display>DocumentLibraryForm</Display>
-  <Edit>DocumentLibraryForm</Edit>
-  <New>DocumentLibraryForm</New>
-</FormTemplates>
+<p:properties xmlns:p="http://schemas.microsoft.com/office/2006/metadata/properties" xmlns:xsi="http://www.w3.org/2001/XMLSchema-instance" xmlns:pc="http://schemas.microsoft.com/office/infopath/2007/PartnerControls">
+  <documentManagement>
+    <_activity xmlns="7f441578-6221-4376-8ce6-60a772b8ffab" xsi:nil="true"/>
+  </documentManagement>
+</p:properties>
 </file>
 
 <file path=customXml/itemProps1.xml><?xml version="1.0" encoding="utf-8"?>
-<ds:datastoreItem xmlns:ds="http://schemas.openxmlformats.org/officeDocument/2006/customXml" ds:itemID="{6D363BA3-762C-463F-93F3-01CBC8DE6D1D}">
+<ds:datastoreItem xmlns:ds="http://schemas.openxmlformats.org/officeDocument/2006/customXml" ds:itemID="{F4810B37-0855-4450-9C32-C6BC2A86203F}">
   <ds:schemaRefs>
-    <ds:schemaRef ds:uri="7f441578-6221-4376-8ce6-60a772b8ffab"/>
-    <ds:schemaRef ds:uri="http://purl.org/dc/elements/1.1/"/>
-    <ds:schemaRef ds:uri="http://purl.org/dc/dcmitype/"/>
-    <ds:schemaRef ds:uri="http://schemas.openxmlformats.org/package/2006/metadata/core-properties"/>
-    <ds:schemaRef ds:uri="http://schemas.microsoft.com/office/2006/documentManagement/types"/>
-    <ds:schemaRef ds:uri="http://purl.org/dc/terms/"/>
-    <ds:schemaRef ds:uri="http://www.w3.org/XML/1998/namespace"/>
-    <ds:schemaRef ds:uri="http://schemas.microsoft.com/office/infopath/2007/PartnerControls"/>
-    <ds:schemaRef ds:uri="http://schemas.microsoft.com/office/2006/metadata/properties"/>
+    <ds:schemaRef ds:uri="http://schemas.microsoft.com/sharepoint/v3/contenttype/forms"/>
   </ds:schemaRefs>
 </ds:datastoreItem>
 </file>
@@ -8544,9 +9045,17 @@
 </file>
 
 <file path=customXml/itemProps3.xml><?xml version="1.0" encoding="utf-8"?>
-<ds:datastoreItem xmlns:ds="http://schemas.openxmlformats.org/officeDocument/2006/customXml" ds:itemID="{F4810B37-0855-4450-9C32-C6BC2A86203F}">
+<ds:datastoreItem xmlns:ds="http://schemas.openxmlformats.org/officeDocument/2006/customXml" ds:itemID="{6D363BA3-762C-463F-93F3-01CBC8DE6D1D}">
   <ds:schemaRefs>
-    <ds:schemaRef ds:uri="http://schemas.microsoft.com/sharepoint/v3/contenttype/forms"/>
+    <ds:schemaRef ds:uri="7f441578-6221-4376-8ce6-60a772b8ffab"/>
+    <ds:schemaRef ds:uri="http://purl.org/dc/elements/1.1/"/>
+    <ds:schemaRef ds:uri="http://purl.org/dc/dcmitype/"/>
+    <ds:schemaRef ds:uri="http://schemas.openxmlformats.org/package/2006/metadata/core-properties"/>
+    <ds:schemaRef ds:uri="http://schemas.microsoft.com/office/2006/documentManagement/types"/>
+    <ds:schemaRef ds:uri="http://purl.org/dc/terms/"/>
+    <ds:schemaRef ds:uri="http://www.w3.org/XML/1998/namespace"/>
+    <ds:schemaRef ds:uri="http://schemas.microsoft.com/office/infopath/2007/PartnerControls"/>
+    <ds:schemaRef ds:uri="http://schemas.microsoft.com/office/2006/metadata/properties"/>
   </ds:schemaRefs>
 </ds:datastoreItem>
 </file>
</xml_diff>